<commit_message>
fix: pin delivery evidence to stable product refs
</commit_message>
<xml_diff>
--- a/output/inbox/customer-project-manager/ShopFlow-v2.6-客户项目经理版.pptx
+++ b/output/inbox/customer-project-manager/ShopFlow-v2.6-客户项目经理版.pptx
@@ -2,16 +2,16 @@
 <file path=ppt/presentation.xml><?xml version="1.0" encoding="utf-8"?>
 <p:presentation xmlns:p="http://schemas.openxmlformats.org/presentationml/2006/main">
   <p:sldMasterIdLst>
-    <p:sldMasterId xmlns:r="http://schemas.openxmlformats.org/officeDocument/2006/relationships" id="2147483648" r:id="Rb0f7578b50cc47f8"/>
+    <p:sldMasterId xmlns:r="http://schemas.openxmlformats.org/officeDocument/2006/relationships" id="2147483648" r:id="R255b188f28fe4bcc"/>
   </p:sldMasterIdLst>
   <p:notesMasterIdLst>
-    <p:notesMasterId xmlns:r="http://schemas.openxmlformats.org/officeDocument/2006/relationships" r:id="R8b1fb185fdd64194"/>
+    <p:notesMasterId xmlns:r="http://schemas.openxmlformats.org/officeDocument/2006/relationships" r:id="R7c33d27bfa704f31"/>
   </p:notesMasterIdLst>
   <p:sldIdLst>
-    <p:sldId xmlns:r="http://schemas.openxmlformats.org/officeDocument/2006/relationships" id="256" r:id="R262c76091f5349eb"/>
-    <p:sldId xmlns:r="http://schemas.openxmlformats.org/officeDocument/2006/relationships" id="257" r:id="Rf9abf21b39f94a10"/>
-    <p:sldId xmlns:r="http://schemas.openxmlformats.org/officeDocument/2006/relationships" id="258" r:id="Rf2923b1d54524e05"/>
-    <p:sldId xmlns:r="http://schemas.openxmlformats.org/officeDocument/2006/relationships" id="259" r:id="R3ff4260e215245fe"/>
+    <p:sldId xmlns:r="http://schemas.openxmlformats.org/officeDocument/2006/relationships" id="256" r:id="Rd5391a5ac4a445d8"/>
+    <p:sldId xmlns:r="http://schemas.openxmlformats.org/officeDocument/2006/relationships" id="257" r:id="R80547df902be49b4"/>
+    <p:sldId xmlns:r="http://schemas.openxmlformats.org/officeDocument/2006/relationships" id="258" r:id="Rdd5f16a06b844c66"/>
+    <p:sldId xmlns:r="http://schemas.openxmlformats.org/officeDocument/2006/relationships" id="259" r:id="R49dc51973b504434"/>
   </p:sldIdLst>
   <p:sldSz cx="12192000" cy="6858000"/>
   <p:notesSz cx="6858000" cy="9144000"/>
@@ -455,7 +455,7 @@
           </a:p>
           <a:p xmlns:a="http://schemas.openxmlformats.org/drawingml/2006/main">
             <a:r>
-              <a:t>- git://shopflow/main@8b67e3d750386b4c993fed848298fa54ff6e2bea</a:t>
+              <a:t>- git://shopflow/product-main@8b67e3d750386b4c993fed848298fa54ff6e2bea</a:t>
             </a:r>
           </a:p>
           <a:p xmlns:a="http://schemas.openxmlformats.org/drawingml/2006/main">
@@ -540,7 +540,7 @@
           </a:p>
           <a:p xmlns:a="http://schemas.openxmlformats.org/drawingml/2006/main">
             <a:r>
-              <a:t>- git://shopflow/main@8b67e3d750386b4c993fed848298fa54ff6e2bea</a:t>
+              <a:t>- git://shopflow/product-main@8b67e3d750386b4c993fed848298fa54ff6e2bea</a:t>
             </a:r>
           </a:p>
           <a:p xmlns:a="http://schemas.openxmlformats.org/drawingml/2006/main">
@@ -700,7 +700,7 @@
           </a:p>
           <a:p xmlns:a="http://schemas.openxmlformats.org/drawingml/2006/main">
             <a:r>
-              <a:t>- git://shopflow/main@8b67e3d750386b4c993fed848298fa54ff6e2bea</a:t>
+              <a:t>- git://shopflow/product-main@8b67e3d750386b4c993fed848298fa54ff6e2bea</a:t>
             </a:r>
           </a:p>
           <a:p xmlns:a="http://schemas.openxmlformats.org/drawingml/2006/main">
@@ -773,7 +773,7 @@
   </p:cSld>
   <p:clrMap bg1="lt1" tx1="dk1" bg2="lt2" tx2="dk2" accent1="accent1" accent2="accent2" accent3="accent3" accent4="accent4" accent5="accent5" accent6="accent6" hlink="hlink" folHlink="folHlink"/>
   <p:sldLayoutIdLst>
-    <p:sldLayoutId xmlns:r="http://schemas.openxmlformats.org/officeDocument/2006/relationships" id="2147483649" r:id="Ra2f4c4642f064da1"/>
+    <p:sldLayoutId xmlns:r="http://schemas.openxmlformats.org/officeDocument/2006/relationships" id="2147483649" r:id="R86e08242fee34f45"/>
   </p:sldLayoutIdLst>
   <p:txStyles>
     <p:titleStyle>
@@ -1324,7 +1324,7 @@
           <p:cNvPr id="7" name="cover-kicker">
             <a:extLst xmlns:a="http://schemas.openxmlformats.org/drawingml/2006/main">
               <a:ext uri="{FF2B5EF4-FFF2-40B4-BE49-F238E27FC236}">
-                <a16:creationId xmlns:a16="http://schemas.microsoft.com/office/drawing/2014/main" id="{9E87FA2C-4018-4576-BADA-98B6C8DDC751}"/>
+                <a16:creationId xmlns:a16="http://schemas.microsoft.com/office/drawing/2014/main" id="{5E124622-5A0D-4419-A306-19D372F579D6}"/>
               </a:ext>
             </a:extLst>
           </p:cNvPr>
@@ -1382,7 +1382,7 @@
           <p:cNvPr id="2" name="cover-title">
             <a:extLst xmlns:a="http://schemas.openxmlformats.org/drawingml/2006/main">
               <a:ext uri="{FF2B5EF4-FFF2-40B4-BE49-F238E27FC236}">
-                <a16:creationId xmlns:a16="http://schemas.microsoft.com/office/drawing/2014/main" id="{EB6DA921-AC96-49C6-ACA4-950A54B584C9}"/>
+                <a16:creationId xmlns:a16="http://schemas.microsoft.com/office/drawing/2014/main" id="{BAB6D25F-32D3-490E-A3AC-03364DD6DD45}"/>
               </a:ext>
             </a:extLst>
           </p:cNvPr>
@@ -1463,7 +1463,7 @@
           <p:cNvPr id="3" name="cover-rule">
             <a:extLst xmlns:a="http://schemas.openxmlformats.org/drawingml/2006/main">
               <a:ext uri="{FF2B5EF4-FFF2-40B4-BE49-F238E27FC236}">
-                <a16:creationId xmlns:a16="http://schemas.microsoft.com/office/drawing/2014/main" id="{35093ABA-0C59-40AB-9863-CC10DCE3EF69}"/>
+                <a16:creationId xmlns:a16="http://schemas.microsoft.com/office/drawing/2014/main" id="{1CFE04F9-3683-4791-BF5B-EB14624FB93C}"/>
               </a:ext>
             </a:extLst>
           </p:cNvPr>
@@ -1494,7 +1494,7 @@
           <p:cNvPr id="4" name="cover-audience">
             <a:extLst xmlns:a="http://schemas.openxmlformats.org/drawingml/2006/main">
               <a:ext uri="{FF2B5EF4-FFF2-40B4-BE49-F238E27FC236}">
-                <a16:creationId xmlns:a16="http://schemas.microsoft.com/office/drawing/2014/main" id="{4EF4F5D3-EB3D-4D6F-A3B1-3477B1DF46EE}"/>
+                <a16:creationId xmlns:a16="http://schemas.microsoft.com/office/drawing/2014/main" id="{B91FBD27-35B8-4EFD-83CD-5F419538A887}"/>
               </a:ext>
             </a:extLst>
           </p:cNvPr>
@@ -1552,7 +1552,7 @@
           <p:cNvPr id="5" name="cover-meta">
             <a:extLst xmlns:a="http://schemas.openxmlformats.org/drawingml/2006/main">
               <a:ext uri="{FF2B5EF4-FFF2-40B4-BE49-F238E27FC236}">
-                <a16:creationId xmlns:a16="http://schemas.microsoft.com/office/drawing/2014/main" id="{E5A1243E-DAB8-460C-9B3E-E9CA92A07014}"/>
+                <a16:creationId xmlns:a16="http://schemas.microsoft.com/office/drawing/2014/main" id="{65ACD460-06C8-4355-9EB7-4C12827858C9}"/>
               </a:ext>
             </a:extLst>
           </p:cNvPr>
@@ -1646,7 +1646,7 @@
                 <a:ea typeface="PingFang SC"/>
                 <a:cs typeface="PingFang SC"/>
               </a:rPr>
-              <a:t>证据快照  shopflow-5bfd99fc6000</a:t>
+              <a:t>证据快照  shopflow-41d613d1137b</a:t>
             </a:r>
           </a:p>
         </p:txBody>
@@ -1656,7 +1656,7 @@
           <p:cNvPr id="6" name="cover-health">
             <a:extLst xmlns:a="http://schemas.openxmlformats.org/drawingml/2006/main">
               <a:ext uri="{FF2B5EF4-FFF2-40B4-BE49-F238E27FC236}">
-                <a16:creationId xmlns:a16="http://schemas.microsoft.com/office/drawing/2014/main" id="{FE370D65-75C4-4F9C-AAC0-EB5E4C88D479}"/>
+                <a16:creationId xmlns:a16="http://schemas.microsoft.com/office/drawing/2014/main" id="{5FBF259B-116A-46C4-B1A6-1E4E43DA5557}"/>
               </a:ext>
             </a:extLst>
           </p:cNvPr>
@@ -1712,7 +1712,7 @@
     </p:spTree>
     <p:extLst>
       <p:ext uri="{BB962C8B-B14F-4D97-AF65-F5344CB8AC3E}">
-        <p14:creationId xmlns:p14="http://schemas.microsoft.com/office/powerpoint/2010/main" val="455711381"/>
+        <p14:creationId xmlns:p14="http://schemas.microsoft.com/office/powerpoint/2010/main" val="626051866"/>
       </p:ext>
     </p:extLst>
   </p:cSld>
@@ -1743,7 +1743,7 @@
           <p:cNvPr id="19" name="title-2">
             <a:extLst xmlns:a="http://schemas.openxmlformats.org/drawingml/2006/main">
               <a:ext uri="{FF2B5EF4-FFF2-40B4-BE49-F238E27FC236}">
-                <a16:creationId xmlns:a16="http://schemas.microsoft.com/office/drawing/2014/main" id="{ADF1CE62-0606-41AD-ACA2-8D0617886E12}"/>
+                <a16:creationId xmlns:a16="http://schemas.microsoft.com/office/drawing/2014/main" id="{B5E838E6-0409-48BB-A7EB-517704103738}"/>
               </a:ext>
             </a:extLst>
           </p:cNvPr>
@@ -1801,7 +1801,7 @@
           <p:cNvPr id="2" name="subtitle-2">
             <a:extLst xmlns:a="http://schemas.openxmlformats.org/drawingml/2006/main">
               <a:ext uri="{FF2B5EF4-FFF2-40B4-BE49-F238E27FC236}">
-                <a16:creationId xmlns:a16="http://schemas.microsoft.com/office/drawing/2014/main" id="{57BACBC0-02EE-498A-8D99-7CEF9935BD2C}"/>
+                <a16:creationId xmlns:a16="http://schemas.microsoft.com/office/drawing/2014/main" id="{2F0A9F44-5C20-487E-B8C0-044917C88E32}"/>
               </a:ext>
             </a:extLst>
           </p:cNvPr>
@@ -1859,7 +1859,7 @@
           <p:cNvPr id="3" name="footer-2">
             <a:extLst xmlns:a="http://schemas.openxmlformats.org/drawingml/2006/main">
               <a:ext uri="{FF2B5EF4-FFF2-40B4-BE49-F238E27FC236}">
-                <a16:creationId xmlns:a16="http://schemas.microsoft.com/office/drawing/2014/main" id="{2629BA25-D9F6-40D7-9099-E3BC01C4FD60}"/>
+                <a16:creationId xmlns:a16="http://schemas.microsoft.com/office/drawing/2014/main" id="{0FE1CEF7-736E-4F4D-9473-E1310C1E4757}"/>
               </a:ext>
             </a:extLst>
           </p:cNvPr>
@@ -1907,7 +1907,7 @@
                 <a:ea typeface="PingFang SC"/>
                 <a:cs typeface="PingFang SC"/>
               </a:rPr>
-              <a:t>ShopFlow v2.6  |  shopflow-5bfd99fc6000</a:t>
+              <a:t>ShopFlow v2.6  |  shopflow-41d613d1137b</a:t>
             </a:r>
           </a:p>
         </p:txBody>
@@ -1917,7 +1917,7 @@
           <p:cNvPr id="4" name="page-2">
             <a:extLst xmlns:a="http://schemas.openxmlformats.org/drawingml/2006/main">
               <a:ext uri="{FF2B5EF4-FFF2-40B4-BE49-F238E27FC236}">
-                <a16:creationId xmlns:a16="http://schemas.microsoft.com/office/drawing/2014/main" id="{26EECE00-DB5E-4628-8403-42799BD50261}"/>
+                <a16:creationId xmlns:a16="http://schemas.microsoft.com/office/drawing/2014/main" id="{DE78BE3C-F315-4C8F-9F9C-6CAD4A7DA1D4}"/>
               </a:ext>
             </a:extLst>
           </p:cNvPr>
@@ -1975,7 +1975,7 @@
           <p:cNvPr id="5" name="progress-number">
             <a:extLst xmlns:a="http://schemas.openxmlformats.org/drawingml/2006/main">
               <a:ext uri="{FF2B5EF4-FFF2-40B4-BE49-F238E27FC236}">
-                <a16:creationId xmlns:a16="http://schemas.microsoft.com/office/drawing/2014/main" id="{345087A0-8B5C-4BCC-BAF8-DBA8F25E4427}"/>
+                <a16:creationId xmlns:a16="http://schemas.microsoft.com/office/drawing/2014/main" id="{C3B13994-65D8-4BF4-914D-657C9A25BB08}"/>
               </a:ext>
             </a:extLst>
           </p:cNvPr>
@@ -2033,7 +2033,7 @@
           <p:cNvPr id="6" name="progress-base">
             <a:extLst xmlns:a="http://schemas.openxmlformats.org/drawingml/2006/main">
               <a:ext uri="{FF2B5EF4-FFF2-40B4-BE49-F238E27FC236}">
-                <a16:creationId xmlns:a16="http://schemas.microsoft.com/office/drawing/2014/main" id="{7B28EA18-1343-4BC7-BD44-41E472D88268}"/>
+                <a16:creationId xmlns:a16="http://schemas.microsoft.com/office/drawing/2014/main" id="{D06D4162-DF55-4E6D-85F9-E3529908868E}"/>
               </a:ext>
             </a:extLst>
           </p:cNvPr>
@@ -2064,7 +2064,7 @@
           <p:cNvPr id="7" name="progress-fill">
             <a:extLst xmlns:a="http://schemas.openxmlformats.org/drawingml/2006/main">
               <a:ext uri="{FF2B5EF4-FFF2-40B4-BE49-F238E27FC236}">
-                <a16:creationId xmlns:a16="http://schemas.microsoft.com/office/drawing/2014/main" id="{EF784258-26B7-4E66-85F8-AE5799AB0A7A}"/>
+                <a16:creationId xmlns:a16="http://schemas.microsoft.com/office/drawing/2014/main" id="{74A44E8A-9019-4BB1-87F7-4049C9B83E0A}"/>
               </a:ext>
             </a:extLst>
           </p:cNvPr>
@@ -2095,7 +2095,7 @@
           <p:cNvPr id="8" name="progress-label">
             <a:extLst xmlns:a="http://schemas.openxmlformats.org/drawingml/2006/main">
               <a:ext uri="{FF2B5EF4-FFF2-40B4-BE49-F238E27FC236}">
-                <a16:creationId xmlns:a16="http://schemas.microsoft.com/office/drawing/2014/main" id="{1EF288C0-F8A2-4A49-9FAA-79FA93E55E36}"/>
+                <a16:creationId xmlns:a16="http://schemas.microsoft.com/office/drawing/2014/main" id="{C60EEC26-D425-488B-AF84-4FBDC1EBA72E}"/>
               </a:ext>
             </a:extLst>
           </p:cNvPr>
@@ -2153,7 +2153,7 @@
           <p:cNvPr id="9" name="stat-bg-0">
             <a:extLst xmlns:a="http://schemas.openxmlformats.org/drawingml/2006/main">
               <a:ext uri="{FF2B5EF4-FFF2-40B4-BE49-F238E27FC236}">
-                <a16:creationId xmlns:a16="http://schemas.microsoft.com/office/drawing/2014/main" id="{FD9FF0EB-1191-4925-9318-1B9FED8FF5F2}"/>
+                <a16:creationId xmlns:a16="http://schemas.microsoft.com/office/drawing/2014/main" id="{582FEE92-12DB-454D-AB57-3478C0CDDA94}"/>
               </a:ext>
             </a:extLst>
           </p:cNvPr>
@@ -2184,7 +2184,7 @@
           <p:cNvPr id="10" name="stat-value-0">
             <a:extLst xmlns:a="http://schemas.openxmlformats.org/drawingml/2006/main">
               <a:ext uri="{FF2B5EF4-FFF2-40B4-BE49-F238E27FC236}">
-                <a16:creationId xmlns:a16="http://schemas.microsoft.com/office/drawing/2014/main" id="{CF566CEC-A950-4533-9B8F-9AB7755E0B74}"/>
+                <a16:creationId xmlns:a16="http://schemas.microsoft.com/office/drawing/2014/main" id="{6A31C212-ECC0-4C4B-A75D-3595438A5C2C}"/>
               </a:ext>
             </a:extLst>
           </p:cNvPr>
@@ -2242,7 +2242,7 @@
           <p:cNvPr id="11" name="stat-label-0">
             <a:extLst xmlns:a="http://schemas.openxmlformats.org/drawingml/2006/main">
               <a:ext uri="{FF2B5EF4-FFF2-40B4-BE49-F238E27FC236}">
-                <a16:creationId xmlns:a16="http://schemas.microsoft.com/office/drawing/2014/main" id="{0F636679-0976-4A84-848A-9A6AFC8ACF66}"/>
+                <a16:creationId xmlns:a16="http://schemas.microsoft.com/office/drawing/2014/main" id="{16703E09-8148-4C0C-9FC8-A09D034E3A79}"/>
               </a:ext>
             </a:extLst>
           </p:cNvPr>
@@ -2300,7 +2300,7 @@
           <p:cNvPr id="12" name="stat-bg-1">
             <a:extLst xmlns:a="http://schemas.openxmlformats.org/drawingml/2006/main">
               <a:ext uri="{FF2B5EF4-FFF2-40B4-BE49-F238E27FC236}">
-                <a16:creationId xmlns:a16="http://schemas.microsoft.com/office/drawing/2014/main" id="{85139FDA-3924-40C5-88B9-360A545F0ED4}"/>
+                <a16:creationId xmlns:a16="http://schemas.microsoft.com/office/drawing/2014/main" id="{C9040E9E-4E5D-44BC-B278-B7C0C2277209}"/>
               </a:ext>
             </a:extLst>
           </p:cNvPr>
@@ -2331,7 +2331,7 @@
           <p:cNvPr id="13" name="stat-value-1">
             <a:extLst xmlns:a="http://schemas.openxmlformats.org/drawingml/2006/main">
               <a:ext uri="{FF2B5EF4-FFF2-40B4-BE49-F238E27FC236}">
-                <a16:creationId xmlns:a16="http://schemas.microsoft.com/office/drawing/2014/main" id="{F4689D41-1989-4B0C-9BD8-25B78E257724}"/>
+                <a16:creationId xmlns:a16="http://schemas.microsoft.com/office/drawing/2014/main" id="{64BD51C7-0851-4FEA-8BFF-E02D4EF511D7}"/>
               </a:ext>
             </a:extLst>
           </p:cNvPr>
@@ -2389,7 +2389,7 @@
           <p:cNvPr id="14" name="stat-label-1">
             <a:extLst xmlns:a="http://schemas.openxmlformats.org/drawingml/2006/main">
               <a:ext uri="{FF2B5EF4-FFF2-40B4-BE49-F238E27FC236}">
-                <a16:creationId xmlns:a16="http://schemas.microsoft.com/office/drawing/2014/main" id="{F643FFC0-476C-4BF3-8AAD-5D2C0B081027}"/>
+                <a16:creationId xmlns:a16="http://schemas.microsoft.com/office/drawing/2014/main" id="{68CEC501-9E58-41A3-9F26-86FAA119770E}"/>
               </a:ext>
             </a:extLst>
           </p:cNvPr>
@@ -2447,7 +2447,7 @@
           <p:cNvPr id="15" name="stat-bg-2">
             <a:extLst xmlns:a="http://schemas.openxmlformats.org/drawingml/2006/main">
               <a:ext uri="{FF2B5EF4-FFF2-40B4-BE49-F238E27FC236}">
-                <a16:creationId xmlns:a16="http://schemas.microsoft.com/office/drawing/2014/main" id="{D2F35F6C-9704-4AB9-8FDB-4FF0A71B2EF7}"/>
+                <a16:creationId xmlns:a16="http://schemas.microsoft.com/office/drawing/2014/main" id="{4861535C-3B3C-4104-836F-FBA90362A750}"/>
               </a:ext>
             </a:extLst>
           </p:cNvPr>
@@ -2478,7 +2478,7 @@
           <p:cNvPr id="16" name="stat-value-2">
             <a:extLst xmlns:a="http://schemas.openxmlformats.org/drawingml/2006/main">
               <a:ext uri="{FF2B5EF4-FFF2-40B4-BE49-F238E27FC236}">
-                <a16:creationId xmlns:a16="http://schemas.microsoft.com/office/drawing/2014/main" id="{B7306AEA-0667-4C80-888F-FE128C98925D}"/>
+                <a16:creationId xmlns:a16="http://schemas.microsoft.com/office/drawing/2014/main" id="{D86991E2-2E85-441B-AD67-248B040C8F2B}"/>
               </a:ext>
             </a:extLst>
           </p:cNvPr>
@@ -2536,7 +2536,7 @@
           <p:cNvPr id="17" name="stat-label-2">
             <a:extLst xmlns:a="http://schemas.openxmlformats.org/drawingml/2006/main">
               <a:ext uri="{FF2B5EF4-FFF2-40B4-BE49-F238E27FC236}">
-                <a16:creationId xmlns:a16="http://schemas.microsoft.com/office/drawing/2014/main" id="{40727A0D-2355-41A0-9098-A87D45F866F1}"/>
+                <a16:creationId xmlns:a16="http://schemas.microsoft.com/office/drawing/2014/main" id="{A92D1084-F989-4EF6-874F-FF80831D8E8A}"/>
               </a:ext>
             </a:extLst>
           </p:cNvPr>
@@ -2594,7 +2594,7 @@
           <p:cNvPr id="18" name="health-conclusion">
             <a:extLst xmlns:a="http://schemas.openxmlformats.org/drawingml/2006/main">
               <a:ext uri="{FF2B5EF4-FFF2-40B4-BE49-F238E27FC236}">
-                <a16:creationId xmlns:a16="http://schemas.microsoft.com/office/drawing/2014/main" id="{F5B12C6A-BCB0-40F1-9836-35BA5E88B70D}"/>
+                <a16:creationId xmlns:a16="http://schemas.microsoft.com/office/drawing/2014/main" id="{E5D70179-0E99-451B-B19C-DD784CE05E2B}"/>
               </a:ext>
             </a:extLst>
           </p:cNvPr>
@@ -2650,7 +2650,7 @@
     </p:spTree>
     <p:extLst>
       <p:ext uri="{BB962C8B-B14F-4D97-AF65-F5344CB8AC3E}">
-        <p14:creationId xmlns:p14="http://schemas.microsoft.com/office/powerpoint/2010/main" val="391225718"/>
+        <p14:creationId xmlns:p14="http://schemas.microsoft.com/office/powerpoint/2010/main" val="1417236030"/>
       </p:ext>
     </p:extLst>
   </p:cSld>
@@ -2681,7 +2681,7 @@
           <p:cNvPr id="53" name="title-3">
             <a:extLst xmlns:a="http://schemas.openxmlformats.org/drawingml/2006/main">
               <a:ext uri="{FF2B5EF4-FFF2-40B4-BE49-F238E27FC236}">
-                <a16:creationId xmlns:a16="http://schemas.microsoft.com/office/drawing/2014/main" id="{B24DAEFD-E453-4FCF-BF40-92386B942533}"/>
+                <a16:creationId xmlns:a16="http://schemas.microsoft.com/office/drawing/2014/main" id="{01E65904-8CAB-4CC0-A8D4-2D448228A3BF}"/>
               </a:ext>
             </a:extLst>
           </p:cNvPr>
@@ -2739,7 +2739,7 @@
           <p:cNvPr id="2" name="subtitle-3">
             <a:extLst xmlns:a="http://schemas.openxmlformats.org/drawingml/2006/main">
               <a:ext uri="{FF2B5EF4-FFF2-40B4-BE49-F238E27FC236}">
-                <a16:creationId xmlns:a16="http://schemas.microsoft.com/office/drawing/2014/main" id="{F36C8CFD-62ED-4CBA-8499-54EE4F166B89}"/>
+                <a16:creationId xmlns:a16="http://schemas.microsoft.com/office/drawing/2014/main" id="{ABAC7FA5-91CC-410B-A37F-9FFE4F0AC07C}"/>
               </a:ext>
             </a:extLst>
           </p:cNvPr>
@@ -2797,7 +2797,7 @@
           <p:cNvPr id="3" name="footer-3">
             <a:extLst xmlns:a="http://schemas.openxmlformats.org/drawingml/2006/main">
               <a:ext uri="{FF2B5EF4-FFF2-40B4-BE49-F238E27FC236}">
-                <a16:creationId xmlns:a16="http://schemas.microsoft.com/office/drawing/2014/main" id="{6C04636C-2D19-46DF-A9CA-36E41FB07F2B}"/>
+                <a16:creationId xmlns:a16="http://schemas.microsoft.com/office/drawing/2014/main" id="{3A08CDD1-44D9-47DD-9A70-88E19D676946}"/>
               </a:ext>
             </a:extLst>
           </p:cNvPr>
@@ -2845,7 +2845,7 @@
                 <a:ea typeface="PingFang SC"/>
                 <a:cs typeface="PingFang SC"/>
               </a:rPr>
-              <a:t>ShopFlow v2.6  |  shopflow-5bfd99fc6000</a:t>
+              <a:t>ShopFlow v2.6  |  shopflow-41d613d1137b</a:t>
             </a:r>
           </a:p>
         </p:txBody>
@@ -2855,7 +2855,7 @@
           <p:cNvPr id="4" name="page-3">
             <a:extLst xmlns:a="http://schemas.openxmlformats.org/drawingml/2006/main">
               <a:ext uri="{FF2B5EF4-FFF2-40B4-BE49-F238E27FC236}">
-                <a16:creationId xmlns:a16="http://schemas.microsoft.com/office/drawing/2014/main" id="{B277B51B-DFB7-4643-9C7F-DFB725010797}"/>
+                <a16:creationId xmlns:a16="http://schemas.microsoft.com/office/drawing/2014/main" id="{A0FD25CF-D71D-4B2B-8A9C-ED97227243D0}"/>
               </a:ext>
             </a:extLst>
           </p:cNvPr>
@@ -2913,7 +2913,7 @@
           <p:cNvPr id="5" name="header-bg-0-180">
             <a:extLst xmlns:a="http://schemas.openxmlformats.org/drawingml/2006/main">
               <a:ext uri="{FF2B5EF4-FFF2-40B4-BE49-F238E27FC236}">
-                <a16:creationId xmlns:a16="http://schemas.microsoft.com/office/drawing/2014/main" id="{CC17F60C-81CA-4596-8F77-9287CDF3511B}"/>
+                <a16:creationId xmlns:a16="http://schemas.microsoft.com/office/drawing/2014/main" id="{E215D55A-B28F-477F-B063-80F96CE1F56E}"/>
               </a:ext>
             </a:extLst>
           </p:cNvPr>
@@ -2944,7 +2944,7 @@
           <p:cNvPr id="6" name="header-0-180">
             <a:extLst xmlns:a="http://schemas.openxmlformats.org/drawingml/2006/main">
               <a:ext uri="{FF2B5EF4-FFF2-40B4-BE49-F238E27FC236}">
-                <a16:creationId xmlns:a16="http://schemas.microsoft.com/office/drawing/2014/main" id="{409E271C-42E9-4F10-8F08-F50FCC641A8D}"/>
+                <a16:creationId xmlns:a16="http://schemas.microsoft.com/office/drawing/2014/main" id="{5037F1F7-6B07-405A-9B8F-1D41FFBEFDDF}"/>
               </a:ext>
             </a:extLst>
           </p:cNvPr>
@@ -3002,7 +3002,7 @@
           <p:cNvPr id="7" name="header-bg-1-180">
             <a:extLst xmlns:a="http://schemas.openxmlformats.org/drawingml/2006/main">
               <a:ext uri="{FF2B5EF4-FFF2-40B4-BE49-F238E27FC236}">
-                <a16:creationId xmlns:a16="http://schemas.microsoft.com/office/drawing/2014/main" id="{D2391EF8-2843-427D-B3C3-C946BFF69D1D}"/>
+                <a16:creationId xmlns:a16="http://schemas.microsoft.com/office/drawing/2014/main" id="{303F98CE-3E3D-4457-BC6F-2D6D959FBE09}"/>
               </a:ext>
             </a:extLst>
           </p:cNvPr>
@@ -3033,7 +3033,7 @@
           <p:cNvPr id="8" name="header-1-180">
             <a:extLst xmlns:a="http://schemas.openxmlformats.org/drawingml/2006/main">
               <a:ext uri="{FF2B5EF4-FFF2-40B4-BE49-F238E27FC236}">
-                <a16:creationId xmlns:a16="http://schemas.microsoft.com/office/drawing/2014/main" id="{95D38936-2243-490D-8E4B-05160B4670F6}"/>
+                <a16:creationId xmlns:a16="http://schemas.microsoft.com/office/drawing/2014/main" id="{A798B2A8-5F9B-4C25-8A37-AE49665F2CED}"/>
               </a:ext>
             </a:extLst>
           </p:cNvPr>
@@ -3091,7 +3091,7 @@
           <p:cNvPr id="9" name="header-bg-2-180">
             <a:extLst xmlns:a="http://schemas.openxmlformats.org/drawingml/2006/main">
               <a:ext uri="{FF2B5EF4-FFF2-40B4-BE49-F238E27FC236}">
-                <a16:creationId xmlns:a16="http://schemas.microsoft.com/office/drawing/2014/main" id="{AEE70517-00E2-4DEB-B907-C11349013F97}"/>
+                <a16:creationId xmlns:a16="http://schemas.microsoft.com/office/drawing/2014/main" id="{147C503A-10CC-4A32-8342-4D61D4193D1E}"/>
               </a:ext>
             </a:extLst>
           </p:cNvPr>
@@ -3122,7 +3122,7 @@
           <p:cNvPr id="10" name="header-2-180">
             <a:extLst xmlns:a="http://schemas.openxmlformats.org/drawingml/2006/main">
               <a:ext uri="{FF2B5EF4-FFF2-40B4-BE49-F238E27FC236}">
-                <a16:creationId xmlns:a16="http://schemas.microsoft.com/office/drawing/2014/main" id="{72DB98E0-B480-4301-8D81-61E0F650EDE5}"/>
+                <a16:creationId xmlns:a16="http://schemas.microsoft.com/office/drawing/2014/main" id="{6E479044-ADCD-4132-8EA8-D1DAE879DB11}"/>
               </a:ext>
             </a:extLst>
           </p:cNvPr>
@@ -3180,7 +3180,7 @@
           <p:cNvPr id="11" name="header-bg-3-180">
             <a:extLst xmlns:a="http://schemas.openxmlformats.org/drawingml/2006/main">
               <a:ext uri="{FF2B5EF4-FFF2-40B4-BE49-F238E27FC236}">
-                <a16:creationId xmlns:a16="http://schemas.microsoft.com/office/drawing/2014/main" id="{BA7D3A5F-53E1-4564-9BB4-69D0BCB3C45A}"/>
+                <a16:creationId xmlns:a16="http://schemas.microsoft.com/office/drawing/2014/main" id="{DF979632-BD27-42F3-BE85-89CCB6CB0708}"/>
               </a:ext>
             </a:extLst>
           </p:cNvPr>
@@ -3211,7 +3211,7 @@
           <p:cNvPr id="12" name="header-3-180">
             <a:extLst xmlns:a="http://schemas.openxmlformats.org/drawingml/2006/main">
               <a:ext uri="{FF2B5EF4-FFF2-40B4-BE49-F238E27FC236}">
-                <a16:creationId xmlns:a16="http://schemas.microsoft.com/office/drawing/2014/main" id="{52A9F6C0-45BA-42E1-855E-91DA07CEA0DB}"/>
+                <a16:creationId xmlns:a16="http://schemas.microsoft.com/office/drawing/2014/main" id="{379BE54C-83BA-4E1B-A41B-E7426C32D0DA}"/>
               </a:ext>
             </a:extLst>
           </p:cNvPr>
@@ -3269,7 +3269,7 @@
           <p:cNvPr id="13" name="cell-bg-0-0-180">
             <a:extLst xmlns:a="http://schemas.openxmlformats.org/drawingml/2006/main">
               <a:ext uri="{FF2B5EF4-FFF2-40B4-BE49-F238E27FC236}">
-                <a16:creationId xmlns:a16="http://schemas.microsoft.com/office/drawing/2014/main" id="{459A7782-5549-4B16-9956-ACA44F576D10}"/>
+                <a16:creationId xmlns:a16="http://schemas.microsoft.com/office/drawing/2014/main" id="{642F99B7-4B5D-4DA5-8BF8-0166DA1C47F1}"/>
               </a:ext>
             </a:extLst>
           </p:cNvPr>
@@ -3302,7 +3302,7 @@
           <p:cNvPr id="14" name="cell-0-0-180">
             <a:extLst xmlns:a="http://schemas.openxmlformats.org/drawingml/2006/main">
               <a:ext uri="{FF2B5EF4-FFF2-40B4-BE49-F238E27FC236}">
-                <a16:creationId xmlns:a16="http://schemas.microsoft.com/office/drawing/2014/main" id="{2B430477-7896-4CE7-8F56-14DE149243E3}"/>
+                <a16:creationId xmlns:a16="http://schemas.microsoft.com/office/drawing/2014/main" id="{136FA9F9-7957-4B97-83A4-18A11ACAD1DD}"/>
               </a:ext>
             </a:extLst>
           </p:cNvPr>
@@ -3360,7 +3360,7 @@
           <p:cNvPr id="15" name="cell-bg-0-1-180">
             <a:extLst xmlns:a="http://schemas.openxmlformats.org/drawingml/2006/main">
               <a:ext uri="{FF2B5EF4-FFF2-40B4-BE49-F238E27FC236}">
-                <a16:creationId xmlns:a16="http://schemas.microsoft.com/office/drawing/2014/main" id="{8FE59351-F41E-40FD-9BB5-86B4FF925CC0}"/>
+                <a16:creationId xmlns:a16="http://schemas.microsoft.com/office/drawing/2014/main" id="{D4133B2C-BEE6-45CC-950B-4BE2858A6578}"/>
               </a:ext>
             </a:extLst>
           </p:cNvPr>
@@ -3393,7 +3393,7 @@
           <p:cNvPr id="16" name="cell-0-1-180">
             <a:extLst xmlns:a="http://schemas.openxmlformats.org/drawingml/2006/main">
               <a:ext uri="{FF2B5EF4-FFF2-40B4-BE49-F238E27FC236}">
-                <a16:creationId xmlns:a16="http://schemas.microsoft.com/office/drawing/2014/main" id="{CD63C116-4C16-42E9-8B26-7CD55C567A59}"/>
+                <a16:creationId xmlns:a16="http://schemas.microsoft.com/office/drawing/2014/main" id="{6F530435-F6B1-4817-BC7F-1F3A945DE07E}"/>
               </a:ext>
             </a:extLst>
           </p:cNvPr>
@@ -3451,7 +3451,7 @@
           <p:cNvPr id="17" name="cell-bg-0-2-180">
             <a:extLst xmlns:a="http://schemas.openxmlformats.org/drawingml/2006/main">
               <a:ext uri="{FF2B5EF4-FFF2-40B4-BE49-F238E27FC236}">
-                <a16:creationId xmlns:a16="http://schemas.microsoft.com/office/drawing/2014/main" id="{7AC1FD21-149A-4503-A694-3905C148DDBE}"/>
+                <a16:creationId xmlns:a16="http://schemas.microsoft.com/office/drawing/2014/main" id="{1DFBBEF8-6343-4A6D-BD50-DB18DEFB4391}"/>
               </a:ext>
             </a:extLst>
           </p:cNvPr>
@@ -3484,7 +3484,7 @@
           <p:cNvPr id="18" name="cell-0-2-180">
             <a:extLst xmlns:a="http://schemas.openxmlformats.org/drawingml/2006/main">
               <a:ext uri="{FF2B5EF4-FFF2-40B4-BE49-F238E27FC236}">
-                <a16:creationId xmlns:a16="http://schemas.microsoft.com/office/drawing/2014/main" id="{F8EBF4A8-1B10-4EF7-AA79-E4C8C73D1A1B}"/>
+                <a16:creationId xmlns:a16="http://schemas.microsoft.com/office/drawing/2014/main" id="{3F7219B3-D5F3-4CF9-BF21-D905BFAB242B}"/>
               </a:ext>
             </a:extLst>
           </p:cNvPr>
@@ -3542,7 +3542,7 @@
           <p:cNvPr id="19" name="cell-bg-0-3-180">
             <a:extLst xmlns:a="http://schemas.openxmlformats.org/drawingml/2006/main">
               <a:ext uri="{FF2B5EF4-FFF2-40B4-BE49-F238E27FC236}">
-                <a16:creationId xmlns:a16="http://schemas.microsoft.com/office/drawing/2014/main" id="{18F5C112-DF06-49D3-8A57-F5C07CC2DD21}"/>
+                <a16:creationId xmlns:a16="http://schemas.microsoft.com/office/drawing/2014/main" id="{6AE035BE-96E9-4738-B7A7-D016F0169280}"/>
               </a:ext>
             </a:extLst>
           </p:cNvPr>
@@ -3575,7 +3575,7 @@
           <p:cNvPr id="20" name="cell-0-3-180">
             <a:extLst xmlns:a="http://schemas.openxmlformats.org/drawingml/2006/main">
               <a:ext uri="{FF2B5EF4-FFF2-40B4-BE49-F238E27FC236}">
-                <a16:creationId xmlns:a16="http://schemas.microsoft.com/office/drawing/2014/main" id="{07DE8E0B-8E67-4BCF-B58F-4B1A4CBDB903}"/>
+                <a16:creationId xmlns:a16="http://schemas.microsoft.com/office/drawing/2014/main" id="{7AF19F85-A236-4C89-8D70-E40C6E804D50}"/>
               </a:ext>
             </a:extLst>
           </p:cNvPr>
@@ -3633,7 +3633,7 @@
           <p:cNvPr id="21" name="cell-bg-1-0-180">
             <a:extLst xmlns:a="http://schemas.openxmlformats.org/drawingml/2006/main">
               <a:ext uri="{FF2B5EF4-FFF2-40B4-BE49-F238E27FC236}">
-                <a16:creationId xmlns:a16="http://schemas.microsoft.com/office/drawing/2014/main" id="{8B99A6A4-58EA-4E67-8D0A-63F0637FDEE6}"/>
+                <a16:creationId xmlns:a16="http://schemas.microsoft.com/office/drawing/2014/main" id="{4B60F237-968D-454A-9217-3E8C8332848F}"/>
               </a:ext>
             </a:extLst>
           </p:cNvPr>
@@ -3666,7 +3666,7 @@
           <p:cNvPr id="22" name="cell-1-0-180">
             <a:extLst xmlns:a="http://schemas.openxmlformats.org/drawingml/2006/main">
               <a:ext uri="{FF2B5EF4-FFF2-40B4-BE49-F238E27FC236}">
-                <a16:creationId xmlns:a16="http://schemas.microsoft.com/office/drawing/2014/main" id="{30C3D64C-1EC7-451D-9636-DD7A6EBEC43F}"/>
+                <a16:creationId xmlns:a16="http://schemas.microsoft.com/office/drawing/2014/main" id="{3EF715C4-7933-4194-A4F9-466092618447}"/>
               </a:ext>
             </a:extLst>
           </p:cNvPr>
@@ -3724,7 +3724,7 @@
           <p:cNvPr id="23" name="cell-bg-1-1-180">
             <a:extLst xmlns:a="http://schemas.openxmlformats.org/drawingml/2006/main">
               <a:ext uri="{FF2B5EF4-FFF2-40B4-BE49-F238E27FC236}">
-                <a16:creationId xmlns:a16="http://schemas.microsoft.com/office/drawing/2014/main" id="{726B9838-4A18-4C48-A923-B60FA08D70C1}"/>
+                <a16:creationId xmlns:a16="http://schemas.microsoft.com/office/drawing/2014/main" id="{94F0B3D9-066A-428D-813B-9886EC1E109E}"/>
               </a:ext>
             </a:extLst>
           </p:cNvPr>
@@ -3757,7 +3757,7 @@
           <p:cNvPr id="24" name="cell-1-1-180">
             <a:extLst xmlns:a="http://schemas.openxmlformats.org/drawingml/2006/main">
               <a:ext uri="{FF2B5EF4-FFF2-40B4-BE49-F238E27FC236}">
-                <a16:creationId xmlns:a16="http://schemas.microsoft.com/office/drawing/2014/main" id="{169906E3-880F-493B-8D95-05F7F0351807}"/>
+                <a16:creationId xmlns:a16="http://schemas.microsoft.com/office/drawing/2014/main" id="{B78900C9-C876-459D-9BAA-1D381C06810C}"/>
               </a:ext>
             </a:extLst>
           </p:cNvPr>
@@ -3815,7 +3815,7 @@
           <p:cNvPr id="25" name="cell-bg-1-2-180">
             <a:extLst xmlns:a="http://schemas.openxmlformats.org/drawingml/2006/main">
               <a:ext uri="{FF2B5EF4-FFF2-40B4-BE49-F238E27FC236}">
-                <a16:creationId xmlns:a16="http://schemas.microsoft.com/office/drawing/2014/main" id="{AD5CBA6E-6A5F-4668-AE22-691F79B453E9}"/>
+                <a16:creationId xmlns:a16="http://schemas.microsoft.com/office/drawing/2014/main" id="{CC7752D9-879C-4BAF-ABEB-3A03BBEDBFD8}"/>
               </a:ext>
             </a:extLst>
           </p:cNvPr>
@@ -3848,7 +3848,7 @@
           <p:cNvPr id="26" name="cell-1-2-180">
             <a:extLst xmlns:a="http://schemas.openxmlformats.org/drawingml/2006/main">
               <a:ext uri="{FF2B5EF4-FFF2-40B4-BE49-F238E27FC236}">
-                <a16:creationId xmlns:a16="http://schemas.microsoft.com/office/drawing/2014/main" id="{EC819B98-B4DC-45C7-8CD5-A0869FCE6C67}"/>
+                <a16:creationId xmlns:a16="http://schemas.microsoft.com/office/drawing/2014/main" id="{2C32371D-C92E-4E87-B2A7-4AB64CAD451C}"/>
               </a:ext>
             </a:extLst>
           </p:cNvPr>
@@ -3906,7 +3906,7 @@
           <p:cNvPr id="27" name="cell-bg-1-3-180">
             <a:extLst xmlns:a="http://schemas.openxmlformats.org/drawingml/2006/main">
               <a:ext uri="{FF2B5EF4-FFF2-40B4-BE49-F238E27FC236}">
-                <a16:creationId xmlns:a16="http://schemas.microsoft.com/office/drawing/2014/main" id="{FB935551-79A4-4F43-AF10-2A42B0A32803}"/>
+                <a16:creationId xmlns:a16="http://schemas.microsoft.com/office/drawing/2014/main" id="{7B7778CD-1135-43CD-8D75-758EF4060FA7}"/>
               </a:ext>
             </a:extLst>
           </p:cNvPr>
@@ -3939,7 +3939,7 @@
           <p:cNvPr id="28" name="cell-1-3-180">
             <a:extLst xmlns:a="http://schemas.openxmlformats.org/drawingml/2006/main">
               <a:ext uri="{FF2B5EF4-FFF2-40B4-BE49-F238E27FC236}">
-                <a16:creationId xmlns:a16="http://schemas.microsoft.com/office/drawing/2014/main" id="{0C308808-36CE-4F76-846E-29918D7AB9D0}"/>
+                <a16:creationId xmlns:a16="http://schemas.microsoft.com/office/drawing/2014/main" id="{CE8EB69C-743B-4050-9A02-B2B9C6529C1D}"/>
               </a:ext>
             </a:extLst>
           </p:cNvPr>
@@ -3997,7 +3997,7 @@
           <p:cNvPr id="29" name="cell-bg-2-0-180">
             <a:extLst xmlns:a="http://schemas.openxmlformats.org/drawingml/2006/main">
               <a:ext uri="{FF2B5EF4-FFF2-40B4-BE49-F238E27FC236}">
-                <a16:creationId xmlns:a16="http://schemas.microsoft.com/office/drawing/2014/main" id="{A6C2572A-FC87-415D-8E03-B682FEF8294F}"/>
+                <a16:creationId xmlns:a16="http://schemas.microsoft.com/office/drawing/2014/main" id="{2C4BDA82-91D6-488A-94BB-5DE056E52BD9}"/>
               </a:ext>
             </a:extLst>
           </p:cNvPr>
@@ -4030,7 +4030,7 @@
           <p:cNvPr id="30" name="cell-2-0-180">
             <a:extLst xmlns:a="http://schemas.openxmlformats.org/drawingml/2006/main">
               <a:ext uri="{FF2B5EF4-FFF2-40B4-BE49-F238E27FC236}">
-                <a16:creationId xmlns:a16="http://schemas.microsoft.com/office/drawing/2014/main" id="{E6AED768-210B-4059-AA7D-4EC681AB0774}"/>
+                <a16:creationId xmlns:a16="http://schemas.microsoft.com/office/drawing/2014/main" id="{A921CBE3-58AE-411C-B0B5-4192A918EB0A}"/>
               </a:ext>
             </a:extLst>
           </p:cNvPr>
@@ -4088,7 +4088,7 @@
           <p:cNvPr id="31" name="cell-bg-2-1-180">
             <a:extLst xmlns:a="http://schemas.openxmlformats.org/drawingml/2006/main">
               <a:ext uri="{FF2B5EF4-FFF2-40B4-BE49-F238E27FC236}">
-                <a16:creationId xmlns:a16="http://schemas.microsoft.com/office/drawing/2014/main" id="{47C8687F-58E4-4246-A86D-5AD46AC8BBB3}"/>
+                <a16:creationId xmlns:a16="http://schemas.microsoft.com/office/drawing/2014/main" id="{D628A99D-5926-41C2-A302-9B2FEBD7DB26}"/>
               </a:ext>
             </a:extLst>
           </p:cNvPr>
@@ -4121,7 +4121,7 @@
           <p:cNvPr id="32" name="cell-2-1-180">
             <a:extLst xmlns:a="http://schemas.openxmlformats.org/drawingml/2006/main">
               <a:ext uri="{FF2B5EF4-FFF2-40B4-BE49-F238E27FC236}">
-                <a16:creationId xmlns:a16="http://schemas.microsoft.com/office/drawing/2014/main" id="{9869BC83-70DF-41B1-BC3B-2692FB7C37FA}"/>
+                <a16:creationId xmlns:a16="http://schemas.microsoft.com/office/drawing/2014/main" id="{2E37027B-97BA-44A3-8915-E574B143E4BB}"/>
               </a:ext>
             </a:extLst>
           </p:cNvPr>
@@ -4179,7 +4179,7 @@
           <p:cNvPr id="33" name="cell-bg-2-2-180">
             <a:extLst xmlns:a="http://schemas.openxmlformats.org/drawingml/2006/main">
               <a:ext uri="{FF2B5EF4-FFF2-40B4-BE49-F238E27FC236}">
-                <a16:creationId xmlns:a16="http://schemas.microsoft.com/office/drawing/2014/main" id="{5AAF7254-EC9B-46A4-9670-CB2DF6E69A7C}"/>
+                <a16:creationId xmlns:a16="http://schemas.microsoft.com/office/drawing/2014/main" id="{435451AF-20CC-4A10-9071-8A41CA6CCB1F}"/>
               </a:ext>
             </a:extLst>
           </p:cNvPr>
@@ -4212,7 +4212,7 @@
           <p:cNvPr id="34" name="cell-2-2-180">
             <a:extLst xmlns:a="http://schemas.openxmlformats.org/drawingml/2006/main">
               <a:ext uri="{FF2B5EF4-FFF2-40B4-BE49-F238E27FC236}">
-                <a16:creationId xmlns:a16="http://schemas.microsoft.com/office/drawing/2014/main" id="{F4450491-C1AA-4EA8-8315-544EB453D3F4}"/>
+                <a16:creationId xmlns:a16="http://schemas.microsoft.com/office/drawing/2014/main" id="{946F2C19-E856-4764-89DD-C9B3CF94C48D}"/>
               </a:ext>
             </a:extLst>
           </p:cNvPr>
@@ -4270,7 +4270,7 @@
           <p:cNvPr id="35" name="cell-bg-2-3-180">
             <a:extLst xmlns:a="http://schemas.openxmlformats.org/drawingml/2006/main">
               <a:ext uri="{FF2B5EF4-FFF2-40B4-BE49-F238E27FC236}">
-                <a16:creationId xmlns:a16="http://schemas.microsoft.com/office/drawing/2014/main" id="{1D0DDB1F-C484-45FE-B7AE-5D045A2B0C33}"/>
+                <a16:creationId xmlns:a16="http://schemas.microsoft.com/office/drawing/2014/main" id="{C3CEB399-ED25-44E0-A9CA-43E5BDD0D0DC}"/>
               </a:ext>
             </a:extLst>
           </p:cNvPr>
@@ -4303,7 +4303,7 @@
           <p:cNvPr id="36" name="cell-2-3-180">
             <a:extLst xmlns:a="http://schemas.openxmlformats.org/drawingml/2006/main">
               <a:ext uri="{FF2B5EF4-FFF2-40B4-BE49-F238E27FC236}">
-                <a16:creationId xmlns:a16="http://schemas.microsoft.com/office/drawing/2014/main" id="{764915C2-CAD1-452D-8B6D-7B3A6572A4AF}"/>
+                <a16:creationId xmlns:a16="http://schemas.microsoft.com/office/drawing/2014/main" id="{AECBA353-11B0-44EA-A034-A4B8427CF3EB}"/>
               </a:ext>
             </a:extLst>
           </p:cNvPr>
@@ -4361,7 +4361,7 @@
           <p:cNvPr id="37" name="cell-bg-3-0-180">
             <a:extLst xmlns:a="http://schemas.openxmlformats.org/drawingml/2006/main">
               <a:ext uri="{FF2B5EF4-FFF2-40B4-BE49-F238E27FC236}">
-                <a16:creationId xmlns:a16="http://schemas.microsoft.com/office/drawing/2014/main" id="{C5FD1824-2354-48B2-B290-04B8AB76126D}"/>
+                <a16:creationId xmlns:a16="http://schemas.microsoft.com/office/drawing/2014/main" id="{14A9C59B-B1D0-4EB9-8AF9-1A02D0EAEE5C}"/>
               </a:ext>
             </a:extLst>
           </p:cNvPr>
@@ -4394,7 +4394,7 @@
           <p:cNvPr id="38" name="cell-3-0-180">
             <a:extLst xmlns:a="http://schemas.openxmlformats.org/drawingml/2006/main">
               <a:ext uri="{FF2B5EF4-FFF2-40B4-BE49-F238E27FC236}">
-                <a16:creationId xmlns:a16="http://schemas.microsoft.com/office/drawing/2014/main" id="{601EED28-A471-45C2-ADAB-80AFAE9D9E59}"/>
+                <a16:creationId xmlns:a16="http://schemas.microsoft.com/office/drawing/2014/main" id="{05FCF409-6403-4F32-BB4C-5E3609AD67FA}"/>
               </a:ext>
             </a:extLst>
           </p:cNvPr>
@@ -4452,7 +4452,7 @@
           <p:cNvPr id="39" name="cell-bg-3-1-180">
             <a:extLst xmlns:a="http://schemas.openxmlformats.org/drawingml/2006/main">
               <a:ext uri="{FF2B5EF4-FFF2-40B4-BE49-F238E27FC236}">
-                <a16:creationId xmlns:a16="http://schemas.microsoft.com/office/drawing/2014/main" id="{779107A0-3CF8-4D83-ACAA-ED31A29B449D}"/>
+                <a16:creationId xmlns:a16="http://schemas.microsoft.com/office/drawing/2014/main" id="{56E51F01-FBB9-4505-B93A-02A687CE3A4D}"/>
               </a:ext>
             </a:extLst>
           </p:cNvPr>
@@ -4485,7 +4485,7 @@
           <p:cNvPr id="40" name="cell-3-1-180">
             <a:extLst xmlns:a="http://schemas.openxmlformats.org/drawingml/2006/main">
               <a:ext uri="{FF2B5EF4-FFF2-40B4-BE49-F238E27FC236}">
-                <a16:creationId xmlns:a16="http://schemas.microsoft.com/office/drawing/2014/main" id="{C8CEE0E4-BE76-4415-AE14-50D5D72D4B9F}"/>
+                <a16:creationId xmlns:a16="http://schemas.microsoft.com/office/drawing/2014/main" id="{7D26DD62-F897-4FA2-B7AD-D0882ECA95C0}"/>
               </a:ext>
             </a:extLst>
           </p:cNvPr>
@@ -4543,7 +4543,7 @@
           <p:cNvPr id="41" name="cell-bg-3-2-180">
             <a:extLst xmlns:a="http://schemas.openxmlformats.org/drawingml/2006/main">
               <a:ext uri="{FF2B5EF4-FFF2-40B4-BE49-F238E27FC236}">
-                <a16:creationId xmlns:a16="http://schemas.microsoft.com/office/drawing/2014/main" id="{BFD7F7AB-090C-4DBD-996C-A8A2B60D7BC6}"/>
+                <a16:creationId xmlns:a16="http://schemas.microsoft.com/office/drawing/2014/main" id="{A2F55B8E-7BEA-4105-9A93-48A11AB1F23E}"/>
               </a:ext>
             </a:extLst>
           </p:cNvPr>
@@ -4576,7 +4576,7 @@
           <p:cNvPr id="42" name="cell-3-2-180">
             <a:extLst xmlns:a="http://schemas.openxmlformats.org/drawingml/2006/main">
               <a:ext uri="{FF2B5EF4-FFF2-40B4-BE49-F238E27FC236}">
-                <a16:creationId xmlns:a16="http://schemas.microsoft.com/office/drawing/2014/main" id="{F1A7F3CF-1C7F-409F-97D7-AB1CE54C0781}"/>
+                <a16:creationId xmlns:a16="http://schemas.microsoft.com/office/drawing/2014/main" id="{4108CB83-E4DD-4DF6-8E1A-914A99868E38}"/>
               </a:ext>
             </a:extLst>
           </p:cNvPr>
@@ -4634,7 +4634,7 @@
           <p:cNvPr id="43" name="cell-bg-3-3-180">
             <a:extLst xmlns:a="http://schemas.openxmlformats.org/drawingml/2006/main">
               <a:ext uri="{FF2B5EF4-FFF2-40B4-BE49-F238E27FC236}">
-                <a16:creationId xmlns:a16="http://schemas.microsoft.com/office/drawing/2014/main" id="{A4D276F9-EA42-4224-8E80-859129B4C315}"/>
+                <a16:creationId xmlns:a16="http://schemas.microsoft.com/office/drawing/2014/main" id="{D9CD7657-C3A5-462F-941A-87F89A419E82}"/>
               </a:ext>
             </a:extLst>
           </p:cNvPr>
@@ -4667,7 +4667,7 @@
           <p:cNvPr id="44" name="cell-3-3-180">
             <a:extLst xmlns:a="http://schemas.openxmlformats.org/drawingml/2006/main">
               <a:ext uri="{FF2B5EF4-FFF2-40B4-BE49-F238E27FC236}">
-                <a16:creationId xmlns:a16="http://schemas.microsoft.com/office/drawing/2014/main" id="{AB47BE8C-9A86-40B0-AED2-0659E8A3D213}"/>
+                <a16:creationId xmlns:a16="http://schemas.microsoft.com/office/drawing/2014/main" id="{5B8598F4-3CD7-49F1-A61C-4441D0872916}"/>
               </a:ext>
             </a:extLst>
           </p:cNvPr>
@@ -4725,7 +4725,7 @@
           <p:cNvPr id="45" name="cell-bg-4-0-180">
             <a:extLst xmlns:a="http://schemas.openxmlformats.org/drawingml/2006/main">
               <a:ext uri="{FF2B5EF4-FFF2-40B4-BE49-F238E27FC236}">
-                <a16:creationId xmlns:a16="http://schemas.microsoft.com/office/drawing/2014/main" id="{8C69EB80-D34E-40DF-8AE4-98BD37BFC86A}"/>
+                <a16:creationId xmlns:a16="http://schemas.microsoft.com/office/drawing/2014/main" id="{CE43CF6E-ECE0-4A34-88B1-2B45D5A7D77B}"/>
               </a:ext>
             </a:extLst>
           </p:cNvPr>
@@ -4758,7 +4758,7 @@
           <p:cNvPr id="46" name="cell-4-0-180">
             <a:extLst xmlns:a="http://schemas.openxmlformats.org/drawingml/2006/main">
               <a:ext uri="{FF2B5EF4-FFF2-40B4-BE49-F238E27FC236}">
-                <a16:creationId xmlns:a16="http://schemas.microsoft.com/office/drawing/2014/main" id="{884B5528-F5FA-4E24-B09D-0EADB26CC917}"/>
+                <a16:creationId xmlns:a16="http://schemas.microsoft.com/office/drawing/2014/main" id="{A46632FE-D199-4E90-BF26-9A72348BB8BF}"/>
               </a:ext>
             </a:extLst>
           </p:cNvPr>
@@ -4816,7 +4816,7 @@
           <p:cNvPr id="47" name="cell-bg-4-1-180">
             <a:extLst xmlns:a="http://schemas.openxmlformats.org/drawingml/2006/main">
               <a:ext uri="{FF2B5EF4-FFF2-40B4-BE49-F238E27FC236}">
-                <a16:creationId xmlns:a16="http://schemas.microsoft.com/office/drawing/2014/main" id="{D7F5986E-854E-4A53-8D36-05BE78B29C2F}"/>
+                <a16:creationId xmlns:a16="http://schemas.microsoft.com/office/drawing/2014/main" id="{C1CA7BD5-2A3B-44AB-9553-0B4BAF6497AD}"/>
               </a:ext>
             </a:extLst>
           </p:cNvPr>
@@ -4849,7 +4849,7 @@
           <p:cNvPr id="48" name="cell-4-1-180">
             <a:extLst xmlns:a="http://schemas.openxmlformats.org/drawingml/2006/main">
               <a:ext uri="{FF2B5EF4-FFF2-40B4-BE49-F238E27FC236}">
-                <a16:creationId xmlns:a16="http://schemas.microsoft.com/office/drawing/2014/main" id="{871FFD0A-67AC-4D3F-80CE-9A8F187CFECF}"/>
+                <a16:creationId xmlns:a16="http://schemas.microsoft.com/office/drawing/2014/main" id="{4D0E8257-0A52-418F-97BE-DF2F0ED60039}"/>
               </a:ext>
             </a:extLst>
           </p:cNvPr>
@@ -4907,7 +4907,7 @@
           <p:cNvPr id="49" name="cell-bg-4-2-180">
             <a:extLst xmlns:a="http://schemas.openxmlformats.org/drawingml/2006/main">
               <a:ext uri="{FF2B5EF4-FFF2-40B4-BE49-F238E27FC236}">
-                <a16:creationId xmlns:a16="http://schemas.microsoft.com/office/drawing/2014/main" id="{AF91A354-4B5D-484B-AAE6-AA6BF06E46E1}"/>
+                <a16:creationId xmlns:a16="http://schemas.microsoft.com/office/drawing/2014/main" id="{BFFD150C-9776-46C0-BBBA-8AFA652EF4A6}"/>
               </a:ext>
             </a:extLst>
           </p:cNvPr>
@@ -4940,7 +4940,7 @@
           <p:cNvPr id="50" name="cell-4-2-180">
             <a:extLst xmlns:a="http://schemas.openxmlformats.org/drawingml/2006/main">
               <a:ext uri="{FF2B5EF4-FFF2-40B4-BE49-F238E27FC236}">
-                <a16:creationId xmlns:a16="http://schemas.microsoft.com/office/drawing/2014/main" id="{767BB492-0B2F-451E-A4BC-CD214E140711}"/>
+                <a16:creationId xmlns:a16="http://schemas.microsoft.com/office/drawing/2014/main" id="{BFF519D7-F8F2-4B21-907C-1D964F788C01}"/>
               </a:ext>
             </a:extLst>
           </p:cNvPr>
@@ -4998,7 +4998,7 @@
           <p:cNvPr id="51" name="cell-bg-4-3-180">
             <a:extLst xmlns:a="http://schemas.openxmlformats.org/drawingml/2006/main">
               <a:ext uri="{FF2B5EF4-FFF2-40B4-BE49-F238E27FC236}">
-                <a16:creationId xmlns:a16="http://schemas.microsoft.com/office/drawing/2014/main" id="{9D9E0249-3375-48F3-A8CF-433EF33A80E8}"/>
+                <a16:creationId xmlns:a16="http://schemas.microsoft.com/office/drawing/2014/main" id="{F688A6C6-0E81-4F6F-B7E4-57B9A7BCE2AB}"/>
               </a:ext>
             </a:extLst>
           </p:cNvPr>
@@ -5031,7 +5031,7 @@
           <p:cNvPr id="52" name="cell-4-3-180">
             <a:extLst xmlns:a="http://schemas.openxmlformats.org/drawingml/2006/main">
               <a:ext uri="{FF2B5EF4-FFF2-40B4-BE49-F238E27FC236}">
-                <a16:creationId xmlns:a16="http://schemas.microsoft.com/office/drawing/2014/main" id="{4A580E78-54AD-48F1-A92E-10CFD98DAC1F}"/>
+                <a16:creationId xmlns:a16="http://schemas.microsoft.com/office/drawing/2014/main" id="{8031273C-1E71-42BD-A8BE-FF2C4FFEB1FB}"/>
               </a:ext>
             </a:extLst>
           </p:cNvPr>
@@ -5087,7 +5087,7 @@
     </p:spTree>
     <p:extLst>
       <p:ext uri="{BB962C8B-B14F-4D97-AF65-F5344CB8AC3E}">
-        <p14:creationId xmlns:p14="http://schemas.microsoft.com/office/powerpoint/2010/main" val="2092564448"/>
+        <p14:creationId xmlns:p14="http://schemas.microsoft.com/office/powerpoint/2010/main" val="41418726"/>
       </p:ext>
     </p:extLst>
   </p:cSld>
@@ -5118,7 +5118,7 @@
           <p:cNvPr id="20" name="title-4">
             <a:extLst xmlns:a="http://schemas.openxmlformats.org/drawingml/2006/main">
               <a:ext uri="{FF2B5EF4-FFF2-40B4-BE49-F238E27FC236}">
-                <a16:creationId xmlns:a16="http://schemas.microsoft.com/office/drawing/2014/main" id="{0E40AB49-2A05-46FA-9845-49B9BB2B0378}"/>
+                <a16:creationId xmlns:a16="http://schemas.microsoft.com/office/drawing/2014/main" id="{7C652201-FBF9-4474-8A37-2D2DAAA2AF15}"/>
               </a:ext>
             </a:extLst>
           </p:cNvPr>
@@ -5176,7 +5176,7 @@
           <p:cNvPr id="2" name="subtitle-4">
             <a:extLst xmlns:a="http://schemas.openxmlformats.org/drawingml/2006/main">
               <a:ext uri="{FF2B5EF4-FFF2-40B4-BE49-F238E27FC236}">
-                <a16:creationId xmlns:a16="http://schemas.microsoft.com/office/drawing/2014/main" id="{592F3D7C-8C8A-4634-8807-CBC05DBEA767}"/>
+                <a16:creationId xmlns:a16="http://schemas.microsoft.com/office/drawing/2014/main" id="{B01CE79C-B64C-41A6-91F1-07D2F627C7BF}"/>
               </a:ext>
             </a:extLst>
           </p:cNvPr>
@@ -5234,7 +5234,7 @@
           <p:cNvPr id="3" name="footer-4">
             <a:extLst xmlns:a="http://schemas.openxmlformats.org/drawingml/2006/main">
               <a:ext uri="{FF2B5EF4-FFF2-40B4-BE49-F238E27FC236}">
-                <a16:creationId xmlns:a16="http://schemas.microsoft.com/office/drawing/2014/main" id="{6BF2CE35-707F-4401-80C7-955234AC5B17}"/>
+                <a16:creationId xmlns:a16="http://schemas.microsoft.com/office/drawing/2014/main" id="{3F58138A-5406-4FD7-92D0-2EC3A0D40FF2}"/>
               </a:ext>
             </a:extLst>
           </p:cNvPr>
@@ -5282,7 +5282,7 @@
                 <a:ea typeface="PingFang SC"/>
                 <a:cs typeface="PingFang SC"/>
               </a:rPr>
-              <a:t>ShopFlow v2.6  |  shopflow-5bfd99fc6000</a:t>
+              <a:t>ShopFlow v2.6  |  shopflow-41d613d1137b</a:t>
             </a:r>
           </a:p>
         </p:txBody>
@@ -5292,7 +5292,7 @@
           <p:cNvPr id="4" name="page-4">
             <a:extLst xmlns:a="http://schemas.openxmlformats.org/drawingml/2006/main">
               <a:ext uri="{FF2B5EF4-FFF2-40B4-BE49-F238E27FC236}">
-                <a16:creationId xmlns:a16="http://schemas.microsoft.com/office/drawing/2014/main" id="{A9C7C7CC-6DD9-4EBB-809E-0E449D22EE5E}"/>
+                <a16:creationId xmlns:a16="http://schemas.microsoft.com/office/drawing/2014/main" id="{E692ACE3-189E-4DBA-B667-EFD67CA7AB54}"/>
               </a:ext>
             </a:extLst>
           </p:cNvPr>
@@ -5350,7 +5350,7 @@
           <p:cNvPr id="5" name="timeline">
             <a:extLst xmlns:a="http://schemas.openxmlformats.org/drawingml/2006/main">
               <a:ext uri="{FF2B5EF4-FFF2-40B4-BE49-F238E27FC236}">
-                <a16:creationId xmlns:a16="http://schemas.microsoft.com/office/drawing/2014/main" id="{2771F41C-7308-4940-917B-31F707F95057}"/>
+                <a16:creationId xmlns:a16="http://schemas.microsoft.com/office/drawing/2014/main" id="{B561DB32-EB20-4505-938F-AF12843C5EF4}"/>
               </a:ext>
             </a:extLst>
           </p:cNvPr>
@@ -5381,7 +5381,7 @@
           <p:cNvPr id="6" name="timeline-dot-0">
             <a:extLst xmlns:a="http://schemas.openxmlformats.org/drawingml/2006/main">
               <a:ext uri="{FF2B5EF4-FFF2-40B4-BE49-F238E27FC236}">
-                <a16:creationId xmlns:a16="http://schemas.microsoft.com/office/drawing/2014/main" id="{B8882EF9-2B6E-4CDF-8910-9C4D5B07BD2F}"/>
+                <a16:creationId xmlns:a16="http://schemas.microsoft.com/office/drawing/2014/main" id="{4CB46FF1-9083-41D8-94F6-C6B4A3EC3EEC}"/>
               </a:ext>
             </a:extLst>
           </p:cNvPr>
@@ -5412,7 +5412,7 @@
           <p:cNvPr id="7" name="timeline-time-0">
             <a:extLst xmlns:a="http://schemas.openxmlformats.org/drawingml/2006/main">
               <a:ext uri="{FF2B5EF4-FFF2-40B4-BE49-F238E27FC236}">
-                <a16:creationId xmlns:a16="http://schemas.microsoft.com/office/drawing/2014/main" id="{53082764-AD6E-44EE-8B3D-AECA75545E92}"/>
+                <a16:creationId xmlns:a16="http://schemas.microsoft.com/office/drawing/2014/main" id="{8F8EF6C5-1095-4829-9F23-BC7F61C0D0BA}"/>
               </a:ext>
             </a:extLst>
           </p:cNvPr>
@@ -5470,7 +5470,7 @@
           <p:cNvPr id="8" name="timeline-title-0">
             <a:extLst xmlns:a="http://schemas.openxmlformats.org/drawingml/2006/main">
               <a:ext uri="{FF2B5EF4-FFF2-40B4-BE49-F238E27FC236}">
-                <a16:creationId xmlns:a16="http://schemas.microsoft.com/office/drawing/2014/main" id="{94D4D475-0E21-4653-9CC5-F1B5DEC9CD1F}"/>
+                <a16:creationId xmlns:a16="http://schemas.microsoft.com/office/drawing/2014/main" id="{4E6C95CC-3DDA-4EF8-9420-18EA04C031AB}"/>
               </a:ext>
             </a:extLst>
           </p:cNvPr>
@@ -5528,7 +5528,7 @@
           <p:cNvPr id="9" name="timeline-owner-0">
             <a:extLst xmlns:a="http://schemas.openxmlformats.org/drawingml/2006/main">
               <a:ext uri="{FF2B5EF4-FFF2-40B4-BE49-F238E27FC236}">
-                <a16:creationId xmlns:a16="http://schemas.microsoft.com/office/drawing/2014/main" id="{774BDB26-DAD3-4232-A495-3A519FBEA5EE}"/>
+                <a16:creationId xmlns:a16="http://schemas.microsoft.com/office/drawing/2014/main" id="{5829EA5B-7270-4934-8D64-FE57BBFCEDBB}"/>
               </a:ext>
             </a:extLst>
           </p:cNvPr>
@@ -5586,7 +5586,7 @@
           <p:cNvPr id="10" name="timeline-dot-1">
             <a:extLst xmlns:a="http://schemas.openxmlformats.org/drawingml/2006/main">
               <a:ext uri="{FF2B5EF4-FFF2-40B4-BE49-F238E27FC236}">
-                <a16:creationId xmlns:a16="http://schemas.microsoft.com/office/drawing/2014/main" id="{CA4FC476-BEB8-4799-BD41-13FA58860C4A}"/>
+                <a16:creationId xmlns:a16="http://schemas.microsoft.com/office/drawing/2014/main" id="{17B9F81C-C867-4D7E-8ACE-0E795108B151}"/>
               </a:ext>
             </a:extLst>
           </p:cNvPr>
@@ -5617,7 +5617,7 @@
           <p:cNvPr id="11" name="timeline-time-1">
             <a:extLst xmlns:a="http://schemas.openxmlformats.org/drawingml/2006/main">
               <a:ext uri="{FF2B5EF4-FFF2-40B4-BE49-F238E27FC236}">
-                <a16:creationId xmlns:a16="http://schemas.microsoft.com/office/drawing/2014/main" id="{24280052-F351-4679-962A-F0F439FA5873}"/>
+                <a16:creationId xmlns:a16="http://schemas.microsoft.com/office/drawing/2014/main" id="{9F9B0E18-D951-4843-B5D8-F2DDEFC131AB}"/>
               </a:ext>
             </a:extLst>
           </p:cNvPr>
@@ -5675,7 +5675,7 @@
           <p:cNvPr id="12" name="timeline-title-1">
             <a:extLst xmlns:a="http://schemas.openxmlformats.org/drawingml/2006/main">
               <a:ext uri="{FF2B5EF4-FFF2-40B4-BE49-F238E27FC236}">
-                <a16:creationId xmlns:a16="http://schemas.microsoft.com/office/drawing/2014/main" id="{406E1C11-397E-4221-86C3-B5FCFFABEA48}"/>
+                <a16:creationId xmlns:a16="http://schemas.microsoft.com/office/drawing/2014/main" id="{2101F749-7747-413C-ABCF-EC4D105A1B42}"/>
               </a:ext>
             </a:extLst>
           </p:cNvPr>
@@ -5733,7 +5733,7 @@
           <p:cNvPr id="13" name="timeline-owner-1">
             <a:extLst xmlns:a="http://schemas.openxmlformats.org/drawingml/2006/main">
               <a:ext uri="{FF2B5EF4-FFF2-40B4-BE49-F238E27FC236}">
-                <a16:creationId xmlns:a16="http://schemas.microsoft.com/office/drawing/2014/main" id="{75B49F0C-3EEE-4BC1-AF47-6B8C93383B71}"/>
+                <a16:creationId xmlns:a16="http://schemas.microsoft.com/office/drawing/2014/main" id="{F4053FBB-A060-428F-9744-21D55DB55E2C}"/>
               </a:ext>
             </a:extLst>
           </p:cNvPr>
@@ -5791,7 +5791,7 @@
           <p:cNvPr id="14" name="timeline-dot-2">
             <a:extLst xmlns:a="http://schemas.openxmlformats.org/drawingml/2006/main">
               <a:ext uri="{FF2B5EF4-FFF2-40B4-BE49-F238E27FC236}">
-                <a16:creationId xmlns:a16="http://schemas.microsoft.com/office/drawing/2014/main" id="{7E7ACA83-4089-444E-A1EF-CBA4B50CDE7E}"/>
+                <a16:creationId xmlns:a16="http://schemas.microsoft.com/office/drawing/2014/main" id="{D4A6537F-9979-4FF7-B3DB-76391AAF95F0}"/>
               </a:ext>
             </a:extLst>
           </p:cNvPr>
@@ -5822,7 +5822,7 @@
           <p:cNvPr id="15" name="timeline-time-2">
             <a:extLst xmlns:a="http://schemas.openxmlformats.org/drawingml/2006/main">
               <a:ext uri="{FF2B5EF4-FFF2-40B4-BE49-F238E27FC236}">
-                <a16:creationId xmlns:a16="http://schemas.microsoft.com/office/drawing/2014/main" id="{0F4EC2F4-007B-4683-976B-0B5D0EE7081A}"/>
+                <a16:creationId xmlns:a16="http://schemas.microsoft.com/office/drawing/2014/main" id="{A5806579-BA9A-443A-AE15-6E8EAFE999AE}"/>
               </a:ext>
             </a:extLst>
           </p:cNvPr>
@@ -5880,7 +5880,7 @@
           <p:cNvPr id="16" name="timeline-title-2">
             <a:extLst xmlns:a="http://schemas.openxmlformats.org/drawingml/2006/main">
               <a:ext uri="{FF2B5EF4-FFF2-40B4-BE49-F238E27FC236}">
-                <a16:creationId xmlns:a16="http://schemas.microsoft.com/office/drawing/2014/main" id="{1A78623A-5A4D-406A-A775-CD86869DC2B8}"/>
+                <a16:creationId xmlns:a16="http://schemas.microsoft.com/office/drawing/2014/main" id="{ABC33878-C516-4703-83C1-16B1AA429B88}"/>
               </a:ext>
             </a:extLst>
           </p:cNvPr>
@@ -5938,7 +5938,7 @@
           <p:cNvPr id="17" name="timeline-owner-2">
             <a:extLst xmlns:a="http://schemas.openxmlformats.org/drawingml/2006/main">
               <a:ext uri="{FF2B5EF4-FFF2-40B4-BE49-F238E27FC236}">
-                <a16:creationId xmlns:a16="http://schemas.microsoft.com/office/drawing/2014/main" id="{72E4F9AE-E388-4EDA-9D67-D064300C3BC4}"/>
+                <a16:creationId xmlns:a16="http://schemas.microsoft.com/office/drawing/2014/main" id="{833E4BED-57C0-41B1-875E-7DCB78D509B2}"/>
               </a:ext>
             </a:extLst>
           </p:cNvPr>
@@ -5996,7 +5996,7 @@
           <p:cNvPr id="18" name="decision-band">
             <a:extLst xmlns:a="http://schemas.openxmlformats.org/drawingml/2006/main">
               <a:ext uri="{FF2B5EF4-FFF2-40B4-BE49-F238E27FC236}">
-                <a16:creationId xmlns:a16="http://schemas.microsoft.com/office/drawing/2014/main" id="{F16EC906-8872-421E-AA07-8066BDAB5922}"/>
+                <a16:creationId xmlns:a16="http://schemas.microsoft.com/office/drawing/2014/main" id="{E29B2DB5-9C3B-419F-92B5-E902CF651ED6}"/>
               </a:ext>
             </a:extLst>
           </p:cNvPr>
@@ -6027,7 +6027,7 @@
           <p:cNvPr id="19" name="decision-text">
             <a:extLst xmlns:a="http://schemas.openxmlformats.org/drawingml/2006/main">
               <a:ext uri="{FF2B5EF4-FFF2-40B4-BE49-F238E27FC236}">
-                <a16:creationId xmlns:a16="http://schemas.microsoft.com/office/drawing/2014/main" id="{970B8E7F-9573-4082-9F19-E3A813BBA4A5}"/>
+                <a16:creationId xmlns:a16="http://schemas.microsoft.com/office/drawing/2014/main" id="{AE3E48BF-EAFE-48C4-BCBA-DE96AB76A969}"/>
               </a:ext>
             </a:extLst>
           </p:cNvPr>
@@ -6083,7 +6083,7 @@
     </p:spTree>
     <p:extLst>
       <p:ext uri="{BB962C8B-B14F-4D97-AF65-F5344CB8AC3E}">
-        <p14:creationId xmlns:p14="http://schemas.microsoft.com/office/powerpoint/2010/main" val="1728303385"/>
+        <p14:creationId xmlns:p14="http://schemas.microsoft.com/office/powerpoint/2010/main" val="173258424"/>
       </p:ext>
     </p:extLst>
   </p:cSld>

</xml_diff>

<commit_message>
docs: bind DuMate case to live GitHub evidence
</commit_message>
<xml_diff>
--- a/output/inbox/customer-project-manager/ShopFlow-v2.6-客户项目经理版.pptx
+++ b/output/inbox/customer-project-manager/ShopFlow-v2.6-客户项目经理版.pptx
@@ -2,16 +2,16 @@
 <file path=ppt/presentation.xml><?xml version="1.0" encoding="utf-8"?>
 <p:presentation xmlns:p="http://schemas.openxmlformats.org/presentationml/2006/main">
   <p:sldMasterIdLst>
-    <p:sldMasterId xmlns:r="http://schemas.openxmlformats.org/officeDocument/2006/relationships" id="2147483648" r:id="R255b188f28fe4bcc"/>
+    <p:sldMasterId xmlns:r="http://schemas.openxmlformats.org/officeDocument/2006/relationships" id="2147483648" r:id="Ra68138b2e4b6444b"/>
   </p:sldMasterIdLst>
   <p:notesMasterIdLst>
-    <p:notesMasterId xmlns:r="http://schemas.openxmlformats.org/officeDocument/2006/relationships" r:id="R7c33d27bfa704f31"/>
+    <p:notesMasterId xmlns:r="http://schemas.openxmlformats.org/officeDocument/2006/relationships" r:id="Rbadc79cd3d0e4d13"/>
   </p:notesMasterIdLst>
   <p:sldIdLst>
-    <p:sldId xmlns:r="http://schemas.openxmlformats.org/officeDocument/2006/relationships" id="256" r:id="Rd5391a5ac4a445d8"/>
-    <p:sldId xmlns:r="http://schemas.openxmlformats.org/officeDocument/2006/relationships" id="257" r:id="R80547df902be49b4"/>
-    <p:sldId xmlns:r="http://schemas.openxmlformats.org/officeDocument/2006/relationships" id="258" r:id="Rdd5f16a06b844c66"/>
-    <p:sldId xmlns:r="http://schemas.openxmlformats.org/officeDocument/2006/relationships" id="259" r:id="R49dc51973b504434"/>
+    <p:sldId xmlns:r="http://schemas.openxmlformats.org/officeDocument/2006/relationships" id="256" r:id="R3eae379736ae4e14"/>
+    <p:sldId xmlns:r="http://schemas.openxmlformats.org/officeDocument/2006/relationships" id="257" r:id="R792eb45780714a52"/>
+    <p:sldId xmlns:r="http://schemas.openxmlformats.org/officeDocument/2006/relationships" id="258" r:id="R5437024b05fb40bb"/>
+    <p:sldId xmlns:r="http://schemas.openxmlformats.org/officeDocument/2006/relationships" id="259" r:id="R0f1735cb25144d04"/>
   </p:sldIdLst>
   <p:sldSz cx="12192000" cy="6858000"/>
   <p:notesSz cx="6858000" cy="9144000"/>
@@ -450,7 +450,7 @@
           </a:p>
           <a:p xmlns:a="http://schemas.openxmlformats.org/drawingml/2006/main">
             <a:r>
-              <a:t>- github://OWNER/ecommerce-delivery-case/milestone/v2.6</a:t>
+              <a:t>- github://pipiwolve/dumate-ecommerce-case/milestone/v2.6</a:t>
             </a:r>
           </a:p>
           <a:p xmlns:a="http://schemas.openxmlformats.org/drawingml/2006/main">
@@ -535,7 +535,7 @@
           </a:p>
           <a:p xmlns:a="http://schemas.openxmlformats.org/drawingml/2006/main">
             <a:r>
-              <a:t>- github://OWNER/ecommerce-delivery-case/milestone/v2.6</a:t>
+              <a:t>- github://pipiwolve/dumate-ecommerce-case/milestone/v2.6</a:t>
             </a:r>
           </a:p>
           <a:p xmlns:a="http://schemas.openxmlformats.org/drawingml/2006/main">
@@ -620,7 +620,7 @@
           </a:p>
           <a:p xmlns:a="http://schemas.openxmlformats.org/drawingml/2006/main">
             <a:r>
-              <a:t>- github://OWNER/ecommerce-delivery-case/milestone/v2.6</a:t>
+              <a:t>- github://pipiwolve/dumate-ecommerce-case/milestone/v2.6</a:t>
             </a:r>
           </a:p>
         </p:txBody>
@@ -695,7 +695,7 @@
           </a:p>
           <a:p xmlns:a="http://schemas.openxmlformats.org/drawingml/2006/main">
             <a:r>
-              <a:t>- github://OWNER/ecommerce-delivery-case/milestone/v2.6</a:t>
+              <a:t>- github://pipiwolve/dumate-ecommerce-case/milestone/v2.6</a:t>
             </a:r>
           </a:p>
           <a:p xmlns:a="http://schemas.openxmlformats.org/drawingml/2006/main">
@@ -773,7 +773,7 @@
   </p:cSld>
   <p:clrMap bg1="lt1" tx1="dk1" bg2="lt2" tx2="dk2" accent1="accent1" accent2="accent2" accent3="accent3" accent4="accent4" accent5="accent5" accent6="accent6" hlink="hlink" folHlink="folHlink"/>
   <p:sldLayoutIdLst>
-    <p:sldLayoutId xmlns:r="http://schemas.openxmlformats.org/officeDocument/2006/relationships" id="2147483649" r:id="R86e08242fee34f45"/>
+    <p:sldLayoutId xmlns:r="http://schemas.openxmlformats.org/officeDocument/2006/relationships" id="2147483649" r:id="R40de5750b5994d2f"/>
   </p:sldLayoutIdLst>
   <p:txStyles>
     <p:titleStyle>
@@ -1324,7 +1324,7 @@
           <p:cNvPr id="7" name="cover-kicker">
             <a:extLst xmlns:a="http://schemas.openxmlformats.org/drawingml/2006/main">
               <a:ext uri="{FF2B5EF4-FFF2-40B4-BE49-F238E27FC236}">
-                <a16:creationId xmlns:a16="http://schemas.microsoft.com/office/drawing/2014/main" id="{5E124622-5A0D-4419-A306-19D372F579D6}"/>
+                <a16:creationId xmlns:a16="http://schemas.microsoft.com/office/drawing/2014/main" id="{207F6E16-15C2-4BC8-87A8-A11737522ECD}"/>
               </a:ext>
             </a:extLst>
           </p:cNvPr>
@@ -1382,7 +1382,7 @@
           <p:cNvPr id="2" name="cover-title">
             <a:extLst xmlns:a="http://schemas.openxmlformats.org/drawingml/2006/main">
               <a:ext uri="{FF2B5EF4-FFF2-40B4-BE49-F238E27FC236}">
-                <a16:creationId xmlns:a16="http://schemas.microsoft.com/office/drawing/2014/main" id="{BAB6D25F-32D3-490E-A3AC-03364DD6DD45}"/>
+                <a16:creationId xmlns:a16="http://schemas.microsoft.com/office/drawing/2014/main" id="{D1F5C834-ECF6-4C03-B57F-23EDF33BF73E}"/>
               </a:ext>
             </a:extLst>
           </p:cNvPr>
@@ -1463,7 +1463,7 @@
           <p:cNvPr id="3" name="cover-rule">
             <a:extLst xmlns:a="http://schemas.openxmlformats.org/drawingml/2006/main">
               <a:ext uri="{FF2B5EF4-FFF2-40B4-BE49-F238E27FC236}">
-                <a16:creationId xmlns:a16="http://schemas.microsoft.com/office/drawing/2014/main" id="{1CFE04F9-3683-4791-BF5B-EB14624FB93C}"/>
+                <a16:creationId xmlns:a16="http://schemas.microsoft.com/office/drawing/2014/main" id="{E20763E2-5369-4813-9DA0-29882BDE9D76}"/>
               </a:ext>
             </a:extLst>
           </p:cNvPr>
@@ -1494,7 +1494,7 @@
           <p:cNvPr id="4" name="cover-audience">
             <a:extLst xmlns:a="http://schemas.openxmlformats.org/drawingml/2006/main">
               <a:ext uri="{FF2B5EF4-FFF2-40B4-BE49-F238E27FC236}">
-                <a16:creationId xmlns:a16="http://schemas.microsoft.com/office/drawing/2014/main" id="{B91FBD27-35B8-4EFD-83CD-5F419538A887}"/>
+                <a16:creationId xmlns:a16="http://schemas.microsoft.com/office/drawing/2014/main" id="{8BEC944C-CC6F-4895-813C-9C8C96CA7D14}"/>
               </a:ext>
             </a:extLst>
           </p:cNvPr>
@@ -1552,7 +1552,7 @@
           <p:cNvPr id="5" name="cover-meta">
             <a:extLst xmlns:a="http://schemas.openxmlformats.org/drawingml/2006/main">
               <a:ext uri="{FF2B5EF4-FFF2-40B4-BE49-F238E27FC236}">
-                <a16:creationId xmlns:a16="http://schemas.microsoft.com/office/drawing/2014/main" id="{65ACD460-06C8-4355-9EB7-4C12827858C9}"/>
+                <a16:creationId xmlns:a16="http://schemas.microsoft.com/office/drawing/2014/main" id="{31656F60-7C72-4B28-844F-ADD73AD24BC9}"/>
               </a:ext>
             </a:extLst>
           </p:cNvPr>
@@ -1646,7 +1646,7 @@
                 <a:ea typeface="PingFang SC"/>
                 <a:cs typeface="PingFang SC"/>
               </a:rPr>
-              <a:t>证据快照  shopflow-41d613d1137b</a:t>
+              <a:t>证据快照  shopflow-fcbc6c1cd435</a:t>
             </a:r>
           </a:p>
         </p:txBody>
@@ -1656,7 +1656,7 @@
           <p:cNvPr id="6" name="cover-health">
             <a:extLst xmlns:a="http://schemas.openxmlformats.org/drawingml/2006/main">
               <a:ext uri="{FF2B5EF4-FFF2-40B4-BE49-F238E27FC236}">
-                <a16:creationId xmlns:a16="http://schemas.microsoft.com/office/drawing/2014/main" id="{5FBF259B-116A-46C4-B1A6-1E4E43DA5557}"/>
+                <a16:creationId xmlns:a16="http://schemas.microsoft.com/office/drawing/2014/main" id="{1A3E7BDA-F8E5-42E2-976F-75EB746A94FF}"/>
               </a:ext>
             </a:extLst>
           </p:cNvPr>
@@ -1712,7 +1712,7 @@
     </p:spTree>
     <p:extLst>
       <p:ext uri="{BB962C8B-B14F-4D97-AF65-F5344CB8AC3E}">
-        <p14:creationId xmlns:p14="http://schemas.microsoft.com/office/powerpoint/2010/main" val="626051866"/>
+        <p14:creationId xmlns:p14="http://schemas.microsoft.com/office/powerpoint/2010/main" val="2003700191"/>
       </p:ext>
     </p:extLst>
   </p:cSld>
@@ -1743,7 +1743,7 @@
           <p:cNvPr id="19" name="title-2">
             <a:extLst xmlns:a="http://schemas.openxmlformats.org/drawingml/2006/main">
               <a:ext uri="{FF2B5EF4-FFF2-40B4-BE49-F238E27FC236}">
-                <a16:creationId xmlns:a16="http://schemas.microsoft.com/office/drawing/2014/main" id="{B5E838E6-0409-48BB-A7EB-517704103738}"/>
+                <a16:creationId xmlns:a16="http://schemas.microsoft.com/office/drawing/2014/main" id="{F55ADF4C-5103-4C88-A1ED-A15E2FCA9095}"/>
               </a:ext>
             </a:extLst>
           </p:cNvPr>
@@ -1801,7 +1801,7 @@
           <p:cNvPr id="2" name="subtitle-2">
             <a:extLst xmlns:a="http://schemas.openxmlformats.org/drawingml/2006/main">
               <a:ext uri="{FF2B5EF4-FFF2-40B4-BE49-F238E27FC236}">
-                <a16:creationId xmlns:a16="http://schemas.microsoft.com/office/drawing/2014/main" id="{2F0A9F44-5C20-487E-B8C0-044917C88E32}"/>
+                <a16:creationId xmlns:a16="http://schemas.microsoft.com/office/drawing/2014/main" id="{89653C3D-D94D-4614-9000-4E65A4EDE63B}"/>
               </a:ext>
             </a:extLst>
           </p:cNvPr>
@@ -1859,7 +1859,7 @@
           <p:cNvPr id="3" name="footer-2">
             <a:extLst xmlns:a="http://schemas.openxmlformats.org/drawingml/2006/main">
               <a:ext uri="{FF2B5EF4-FFF2-40B4-BE49-F238E27FC236}">
-                <a16:creationId xmlns:a16="http://schemas.microsoft.com/office/drawing/2014/main" id="{0FE1CEF7-736E-4F4D-9473-E1310C1E4757}"/>
+                <a16:creationId xmlns:a16="http://schemas.microsoft.com/office/drawing/2014/main" id="{DC14C201-2DE5-4B82-B569-C06D9FDAA4BD}"/>
               </a:ext>
             </a:extLst>
           </p:cNvPr>
@@ -1907,7 +1907,7 @@
                 <a:ea typeface="PingFang SC"/>
                 <a:cs typeface="PingFang SC"/>
               </a:rPr>
-              <a:t>ShopFlow v2.6  |  shopflow-41d613d1137b</a:t>
+              <a:t>ShopFlow v2.6  |  shopflow-fcbc6c1cd435</a:t>
             </a:r>
           </a:p>
         </p:txBody>
@@ -1917,7 +1917,7 @@
           <p:cNvPr id="4" name="page-2">
             <a:extLst xmlns:a="http://schemas.openxmlformats.org/drawingml/2006/main">
               <a:ext uri="{FF2B5EF4-FFF2-40B4-BE49-F238E27FC236}">
-                <a16:creationId xmlns:a16="http://schemas.microsoft.com/office/drawing/2014/main" id="{DE78BE3C-F315-4C8F-9F9C-6CAD4A7DA1D4}"/>
+                <a16:creationId xmlns:a16="http://schemas.microsoft.com/office/drawing/2014/main" id="{516CCC55-8999-4188-A96A-C446D012EEAB}"/>
               </a:ext>
             </a:extLst>
           </p:cNvPr>
@@ -1975,7 +1975,7 @@
           <p:cNvPr id="5" name="progress-number">
             <a:extLst xmlns:a="http://schemas.openxmlformats.org/drawingml/2006/main">
               <a:ext uri="{FF2B5EF4-FFF2-40B4-BE49-F238E27FC236}">
-                <a16:creationId xmlns:a16="http://schemas.microsoft.com/office/drawing/2014/main" id="{C3B13994-65D8-4BF4-914D-657C9A25BB08}"/>
+                <a16:creationId xmlns:a16="http://schemas.microsoft.com/office/drawing/2014/main" id="{A4B64153-DE4D-4F6D-9730-A71CD4F8E52F}"/>
               </a:ext>
             </a:extLst>
           </p:cNvPr>
@@ -2033,7 +2033,7 @@
           <p:cNvPr id="6" name="progress-base">
             <a:extLst xmlns:a="http://schemas.openxmlformats.org/drawingml/2006/main">
               <a:ext uri="{FF2B5EF4-FFF2-40B4-BE49-F238E27FC236}">
-                <a16:creationId xmlns:a16="http://schemas.microsoft.com/office/drawing/2014/main" id="{D06D4162-DF55-4E6D-85F9-E3529908868E}"/>
+                <a16:creationId xmlns:a16="http://schemas.microsoft.com/office/drawing/2014/main" id="{7ED3E2D0-5AA0-4441-AB9E-FF1748A732AB}"/>
               </a:ext>
             </a:extLst>
           </p:cNvPr>
@@ -2064,7 +2064,7 @@
           <p:cNvPr id="7" name="progress-fill">
             <a:extLst xmlns:a="http://schemas.openxmlformats.org/drawingml/2006/main">
               <a:ext uri="{FF2B5EF4-FFF2-40B4-BE49-F238E27FC236}">
-                <a16:creationId xmlns:a16="http://schemas.microsoft.com/office/drawing/2014/main" id="{74A44E8A-9019-4BB1-87F7-4049C9B83E0A}"/>
+                <a16:creationId xmlns:a16="http://schemas.microsoft.com/office/drawing/2014/main" id="{8A03C19B-0163-4A86-8D82-A977383FC5E6}"/>
               </a:ext>
             </a:extLst>
           </p:cNvPr>
@@ -2095,7 +2095,7 @@
           <p:cNvPr id="8" name="progress-label">
             <a:extLst xmlns:a="http://schemas.openxmlformats.org/drawingml/2006/main">
               <a:ext uri="{FF2B5EF4-FFF2-40B4-BE49-F238E27FC236}">
-                <a16:creationId xmlns:a16="http://schemas.microsoft.com/office/drawing/2014/main" id="{C60EEC26-D425-488B-AF84-4FBDC1EBA72E}"/>
+                <a16:creationId xmlns:a16="http://schemas.microsoft.com/office/drawing/2014/main" id="{DF9627D4-6556-49E9-9780-4224C99C329B}"/>
               </a:ext>
             </a:extLst>
           </p:cNvPr>
@@ -2153,7 +2153,7 @@
           <p:cNvPr id="9" name="stat-bg-0">
             <a:extLst xmlns:a="http://schemas.openxmlformats.org/drawingml/2006/main">
               <a:ext uri="{FF2B5EF4-FFF2-40B4-BE49-F238E27FC236}">
-                <a16:creationId xmlns:a16="http://schemas.microsoft.com/office/drawing/2014/main" id="{582FEE92-12DB-454D-AB57-3478C0CDDA94}"/>
+                <a16:creationId xmlns:a16="http://schemas.microsoft.com/office/drawing/2014/main" id="{277053FB-3AAE-4562-B2CD-B062AC64E2C8}"/>
               </a:ext>
             </a:extLst>
           </p:cNvPr>
@@ -2184,7 +2184,7 @@
           <p:cNvPr id="10" name="stat-value-0">
             <a:extLst xmlns:a="http://schemas.openxmlformats.org/drawingml/2006/main">
               <a:ext uri="{FF2B5EF4-FFF2-40B4-BE49-F238E27FC236}">
-                <a16:creationId xmlns:a16="http://schemas.microsoft.com/office/drawing/2014/main" id="{6A31C212-ECC0-4C4B-A75D-3595438A5C2C}"/>
+                <a16:creationId xmlns:a16="http://schemas.microsoft.com/office/drawing/2014/main" id="{6860CAC5-77AE-4B27-92FD-9A36C6F70FDA}"/>
               </a:ext>
             </a:extLst>
           </p:cNvPr>
@@ -2242,7 +2242,7 @@
           <p:cNvPr id="11" name="stat-label-0">
             <a:extLst xmlns:a="http://schemas.openxmlformats.org/drawingml/2006/main">
               <a:ext uri="{FF2B5EF4-FFF2-40B4-BE49-F238E27FC236}">
-                <a16:creationId xmlns:a16="http://schemas.microsoft.com/office/drawing/2014/main" id="{16703E09-8148-4C0C-9FC8-A09D034E3A79}"/>
+                <a16:creationId xmlns:a16="http://schemas.microsoft.com/office/drawing/2014/main" id="{CA182FC0-435A-47EB-94AD-9714416B6969}"/>
               </a:ext>
             </a:extLst>
           </p:cNvPr>
@@ -2300,7 +2300,7 @@
           <p:cNvPr id="12" name="stat-bg-1">
             <a:extLst xmlns:a="http://schemas.openxmlformats.org/drawingml/2006/main">
               <a:ext uri="{FF2B5EF4-FFF2-40B4-BE49-F238E27FC236}">
-                <a16:creationId xmlns:a16="http://schemas.microsoft.com/office/drawing/2014/main" id="{C9040E9E-4E5D-44BC-B278-B7C0C2277209}"/>
+                <a16:creationId xmlns:a16="http://schemas.microsoft.com/office/drawing/2014/main" id="{ECB34222-B843-4913-8DA3-70011F0EBB7D}"/>
               </a:ext>
             </a:extLst>
           </p:cNvPr>
@@ -2331,7 +2331,7 @@
           <p:cNvPr id="13" name="stat-value-1">
             <a:extLst xmlns:a="http://schemas.openxmlformats.org/drawingml/2006/main">
               <a:ext uri="{FF2B5EF4-FFF2-40B4-BE49-F238E27FC236}">
-                <a16:creationId xmlns:a16="http://schemas.microsoft.com/office/drawing/2014/main" id="{64BD51C7-0851-4FEA-8BFF-E02D4EF511D7}"/>
+                <a16:creationId xmlns:a16="http://schemas.microsoft.com/office/drawing/2014/main" id="{EB3A4325-2092-43C6-8CC6-2FF8D1C6192A}"/>
               </a:ext>
             </a:extLst>
           </p:cNvPr>
@@ -2389,7 +2389,7 @@
           <p:cNvPr id="14" name="stat-label-1">
             <a:extLst xmlns:a="http://schemas.openxmlformats.org/drawingml/2006/main">
               <a:ext uri="{FF2B5EF4-FFF2-40B4-BE49-F238E27FC236}">
-                <a16:creationId xmlns:a16="http://schemas.microsoft.com/office/drawing/2014/main" id="{68CEC501-9E58-41A3-9F26-86FAA119770E}"/>
+                <a16:creationId xmlns:a16="http://schemas.microsoft.com/office/drawing/2014/main" id="{0D9722C0-8024-457A-83B4-02A79CE5819B}"/>
               </a:ext>
             </a:extLst>
           </p:cNvPr>
@@ -2447,7 +2447,7 @@
           <p:cNvPr id="15" name="stat-bg-2">
             <a:extLst xmlns:a="http://schemas.openxmlformats.org/drawingml/2006/main">
               <a:ext uri="{FF2B5EF4-FFF2-40B4-BE49-F238E27FC236}">
-                <a16:creationId xmlns:a16="http://schemas.microsoft.com/office/drawing/2014/main" id="{4861535C-3B3C-4104-836F-FBA90362A750}"/>
+                <a16:creationId xmlns:a16="http://schemas.microsoft.com/office/drawing/2014/main" id="{CC3D5247-6451-465D-82CC-C8C31FD98815}"/>
               </a:ext>
             </a:extLst>
           </p:cNvPr>
@@ -2478,7 +2478,7 @@
           <p:cNvPr id="16" name="stat-value-2">
             <a:extLst xmlns:a="http://schemas.openxmlformats.org/drawingml/2006/main">
               <a:ext uri="{FF2B5EF4-FFF2-40B4-BE49-F238E27FC236}">
-                <a16:creationId xmlns:a16="http://schemas.microsoft.com/office/drawing/2014/main" id="{D86991E2-2E85-441B-AD67-248B040C8F2B}"/>
+                <a16:creationId xmlns:a16="http://schemas.microsoft.com/office/drawing/2014/main" id="{C1BC3520-E5F2-43BC-9F3C-B55999DE856B}"/>
               </a:ext>
             </a:extLst>
           </p:cNvPr>
@@ -2536,7 +2536,7 @@
           <p:cNvPr id="17" name="stat-label-2">
             <a:extLst xmlns:a="http://schemas.openxmlformats.org/drawingml/2006/main">
               <a:ext uri="{FF2B5EF4-FFF2-40B4-BE49-F238E27FC236}">
-                <a16:creationId xmlns:a16="http://schemas.microsoft.com/office/drawing/2014/main" id="{A92D1084-F989-4EF6-874F-FF80831D8E8A}"/>
+                <a16:creationId xmlns:a16="http://schemas.microsoft.com/office/drawing/2014/main" id="{41347020-0082-40B7-A151-683EA16E32AC}"/>
               </a:ext>
             </a:extLst>
           </p:cNvPr>
@@ -2594,7 +2594,7 @@
           <p:cNvPr id="18" name="health-conclusion">
             <a:extLst xmlns:a="http://schemas.openxmlformats.org/drawingml/2006/main">
               <a:ext uri="{FF2B5EF4-FFF2-40B4-BE49-F238E27FC236}">
-                <a16:creationId xmlns:a16="http://schemas.microsoft.com/office/drawing/2014/main" id="{E5D70179-0E99-451B-B19C-DD784CE05E2B}"/>
+                <a16:creationId xmlns:a16="http://schemas.microsoft.com/office/drawing/2014/main" id="{3CC3F8E0-16CE-4128-BD23-0BA520D16A00}"/>
               </a:ext>
             </a:extLst>
           </p:cNvPr>
@@ -2650,7 +2650,7 @@
     </p:spTree>
     <p:extLst>
       <p:ext uri="{BB962C8B-B14F-4D97-AF65-F5344CB8AC3E}">
-        <p14:creationId xmlns:p14="http://schemas.microsoft.com/office/powerpoint/2010/main" val="1417236030"/>
+        <p14:creationId xmlns:p14="http://schemas.microsoft.com/office/powerpoint/2010/main" val="1737423043"/>
       </p:ext>
     </p:extLst>
   </p:cSld>
@@ -2681,7 +2681,7 @@
           <p:cNvPr id="53" name="title-3">
             <a:extLst xmlns:a="http://schemas.openxmlformats.org/drawingml/2006/main">
               <a:ext uri="{FF2B5EF4-FFF2-40B4-BE49-F238E27FC236}">
-                <a16:creationId xmlns:a16="http://schemas.microsoft.com/office/drawing/2014/main" id="{01E65904-8CAB-4CC0-A8D4-2D448228A3BF}"/>
+                <a16:creationId xmlns:a16="http://schemas.microsoft.com/office/drawing/2014/main" id="{F64557DE-2D40-47B2-AE3E-D8F6C77BE55C}"/>
               </a:ext>
             </a:extLst>
           </p:cNvPr>
@@ -2739,7 +2739,7 @@
           <p:cNvPr id="2" name="subtitle-3">
             <a:extLst xmlns:a="http://schemas.openxmlformats.org/drawingml/2006/main">
               <a:ext uri="{FF2B5EF4-FFF2-40B4-BE49-F238E27FC236}">
-                <a16:creationId xmlns:a16="http://schemas.microsoft.com/office/drawing/2014/main" id="{ABAC7FA5-91CC-410B-A37F-9FFE4F0AC07C}"/>
+                <a16:creationId xmlns:a16="http://schemas.microsoft.com/office/drawing/2014/main" id="{FA677653-CC4E-4401-9D3E-DF619D0CE5CC}"/>
               </a:ext>
             </a:extLst>
           </p:cNvPr>
@@ -2797,7 +2797,7 @@
           <p:cNvPr id="3" name="footer-3">
             <a:extLst xmlns:a="http://schemas.openxmlformats.org/drawingml/2006/main">
               <a:ext uri="{FF2B5EF4-FFF2-40B4-BE49-F238E27FC236}">
-                <a16:creationId xmlns:a16="http://schemas.microsoft.com/office/drawing/2014/main" id="{3A08CDD1-44D9-47DD-9A70-88E19D676946}"/>
+                <a16:creationId xmlns:a16="http://schemas.microsoft.com/office/drawing/2014/main" id="{DB6B76E9-2B39-457D-A2E9-BA34924AD669}"/>
               </a:ext>
             </a:extLst>
           </p:cNvPr>
@@ -2845,7 +2845,7 @@
                 <a:ea typeface="PingFang SC"/>
                 <a:cs typeface="PingFang SC"/>
               </a:rPr>
-              <a:t>ShopFlow v2.6  |  shopflow-41d613d1137b</a:t>
+              <a:t>ShopFlow v2.6  |  shopflow-fcbc6c1cd435</a:t>
             </a:r>
           </a:p>
         </p:txBody>
@@ -2855,7 +2855,7 @@
           <p:cNvPr id="4" name="page-3">
             <a:extLst xmlns:a="http://schemas.openxmlformats.org/drawingml/2006/main">
               <a:ext uri="{FF2B5EF4-FFF2-40B4-BE49-F238E27FC236}">
-                <a16:creationId xmlns:a16="http://schemas.microsoft.com/office/drawing/2014/main" id="{A0FD25CF-D71D-4B2B-8A9C-ED97227243D0}"/>
+                <a16:creationId xmlns:a16="http://schemas.microsoft.com/office/drawing/2014/main" id="{6E36A572-EB00-4687-91B7-703512F5B962}"/>
               </a:ext>
             </a:extLst>
           </p:cNvPr>
@@ -2913,7 +2913,7 @@
           <p:cNvPr id="5" name="header-bg-0-180">
             <a:extLst xmlns:a="http://schemas.openxmlformats.org/drawingml/2006/main">
               <a:ext uri="{FF2B5EF4-FFF2-40B4-BE49-F238E27FC236}">
-                <a16:creationId xmlns:a16="http://schemas.microsoft.com/office/drawing/2014/main" id="{E215D55A-B28F-477F-B063-80F96CE1F56E}"/>
+                <a16:creationId xmlns:a16="http://schemas.microsoft.com/office/drawing/2014/main" id="{DEC7E970-A883-48C0-9647-31A8CD64E18E}"/>
               </a:ext>
             </a:extLst>
           </p:cNvPr>
@@ -2944,7 +2944,7 @@
           <p:cNvPr id="6" name="header-0-180">
             <a:extLst xmlns:a="http://schemas.openxmlformats.org/drawingml/2006/main">
               <a:ext uri="{FF2B5EF4-FFF2-40B4-BE49-F238E27FC236}">
-                <a16:creationId xmlns:a16="http://schemas.microsoft.com/office/drawing/2014/main" id="{5037F1F7-6B07-405A-9B8F-1D41FFBEFDDF}"/>
+                <a16:creationId xmlns:a16="http://schemas.microsoft.com/office/drawing/2014/main" id="{BEA78F4B-A28C-4AF2-951C-DBEBF986CDAA}"/>
               </a:ext>
             </a:extLst>
           </p:cNvPr>
@@ -3002,7 +3002,7 @@
           <p:cNvPr id="7" name="header-bg-1-180">
             <a:extLst xmlns:a="http://schemas.openxmlformats.org/drawingml/2006/main">
               <a:ext uri="{FF2B5EF4-FFF2-40B4-BE49-F238E27FC236}">
-                <a16:creationId xmlns:a16="http://schemas.microsoft.com/office/drawing/2014/main" id="{303F98CE-3E3D-4457-BC6F-2D6D959FBE09}"/>
+                <a16:creationId xmlns:a16="http://schemas.microsoft.com/office/drawing/2014/main" id="{AC2DDE15-8953-4437-A337-D699B1B3037B}"/>
               </a:ext>
             </a:extLst>
           </p:cNvPr>
@@ -3033,7 +3033,7 @@
           <p:cNvPr id="8" name="header-1-180">
             <a:extLst xmlns:a="http://schemas.openxmlformats.org/drawingml/2006/main">
               <a:ext uri="{FF2B5EF4-FFF2-40B4-BE49-F238E27FC236}">
-                <a16:creationId xmlns:a16="http://schemas.microsoft.com/office/drawing/2014/main" id="{A798B2A8-5F9B-4C25-8A37-AE49665F2CED}"/>
+                <a16:creationId xmlns:a16="http://schemas.microsoft.com/office/drawing/2014/main" id="{6B42A891-623A-4F7B-B083-A35B860272BC}"/>
               </a:ext>
             </a:extLst>
           </p:cNvPr>
@@ -3091,7 +3091,7 @@
           <p:cNvPr id="9" name="header-bg-2-180">
             <a:extLst xmlns:a="http://schemas.openxmlformats.org/drawingml/2006/main">
               <a:ext uri="{FF2B5EF4-FFF2-40B4-BE49-F238E27FC236}">
-                <a16:creationId xmlns:a16="http://schemas.microsoft.com/office/drawing/2014/main" id="{147C503A-10CC-4A32-8342-4D61D4193D1E}"/>
+                <a16:creationId xmlns:a16="http://schemas.microsoft.com/office/drawing/2014/main" id="{D8F90C13-0639-48BA-930B-343FC3F11DF1}"/>
               </a:ext>
             </a:extLst>
           </p:cNvPr>
@@ -3122,7 +3122,7 @@
           <p:cNvPr id="10" name="header-2-180">
             <a:extLst xmlns:a="http://schemas.openxmlformats.org/drawingml/2006/main">
               <a:ext uri="{FF2B5EF4-FFF2-40B4-BE49-F238E27FC236}">
-                <a16:creationId xmlns:a16="http://schemas.microsoft.com/office/drawing/2014/main" id="{6E479044-ADCD-4132-8EA8-D1DAE879DB11}"/>
+                <a16:creationId xmlns:a16="http://schemas.microsoft.com/office/drawing/2014/main" id="{5DC9A076-99D3-4BEE-8698-9E7EC0D5286D}"/>
               </a:ext>
             </a:extLst>
           </p:cNvPr>
@@ -3180,7 +3180,7 @@
           <p:cNvPr id="11" name="header-bg-3-180">
             <a:extLst xmlns:a="http://schemas.openxmlformats.org/drawingml/2006/main">
               <a:ext uri="{FF2B5EF4-FFF2-40B4-BE49-F238E27FC236}">
-                <a16:creationId xmlns:a16="http://schemas.microsoft.com/office/drawing/2014/main" id="{DF979632-BD27-42F3-BE85-89CCB6CB0708}"/>
+                <a16:creationId xmlns:a16="http://schemas.microsoft.com/office/drawing/2014/main" id="{A12D442B-3968-47AF-BE11-8833B6D5CB2D}"/>
               </a:ext>
             </a:extLst>
           </p:cNvPr>
@@ -3211,7 +3211,7 @@
           <p:cNvPr id="12" name="header-3-180">
             <a:extLst xmlns:a="http://schemas.openxmlformats.org/drawingml/2006/main">
               <a:ext uri="{FF2B5EF4-FFF2-40B4-BE49-F238E27FC236}">
-                <a16:creationId xmlns:a16="http://schemas.microsoft.com/office/drawing/2014/main" id="{379BE54C-83BA-4E1B-A41B-E7426C32D0DA}"/>
+                <a16:creationId xmlns:a16="http://schemas.microsoft.com/office/drawing/2014/main" id="{F9F7A355-E9FF-4843-8482-3E2615E83929}"/>
               </a:ext>
             </a:extLst>
           </p:cNvPr>
@@ -3269,7 +3269,7 @@
           <p:cNvPr id="13" name="cell-bg-0-0-180">
             <a:extLst xmlns:a="http://schemas.openxmlformats.org/drawingml/2006/main">
               <a:ext uri="{FF2B5EF4-FFF2-40B4-BE49-F238E27FC236}">
-                <a16:creationId xmlns:a16="http://schemas.microsoft.com/office/drawing/2014/main" id="{642F99B7-4B5D-4DA5-8BF8-0166DA1C47F1}"/>
+                <a16:creationId xmlns:a16="http://schemas.microsoft.com/office/drawing/2014/main" id="{AD0BB189-B833-413B-96DC-255719FB4384}"/>
               </a:ext>
             </a:extLst>
           </p:cNvPr>
@@ -3302,7 +3302,7 @@
           <p:cNvPr id="14" name="cell-0-0-180">
             <a:extLst xmlns:a="http://schemas.openxmlformats.org/drawingml/2006/main">
               <a:ext uri="{FF2B5EF4-FFF2-40B4-BE49-F238E27FC236}">
-                <a16:creationId xmlns:a16="http://schemas.microsoft.com/office/drawing/2014/main" id="{136FA9F9-7957-4B97-83A4-18A11ACAD1DD}"/>
+                <a16:creationId xmlns:a16="http://schemas.microsoft.com/office/drawing/2014/main" id="{47910F6E-BA89-45DE-98EF-DD6F87C6891B}"/>
               </a:ext>
             </a:extLst>
           </p:cNvPr>
@@ -3360,7 +3360,7 @@
           <p:cNvPr id="15" name="cell-bg-0-1-180">
             <a:extLst xmlns:a="http://schemas.openxmlformats.org/drawingml/2006/main">
               <a:ext uri="{FF2B5EF4-FFF2-40B4-BE49-F238E27FC236}">
-                <a16:creationId xmlns:a16="http://schemas.microsoft.com/office/drawing/2014/main" id="{D4133B2C-BEE6-45CC-950B-4BE2858A6578}"/>
+                <a16:creationId xmlns:a16="http://schemas.microsoft.com/office/drawing/2014/main" id="{5EECB3B8-D8A4-4287-8994-3B7BD54079F3}"/>
               </a:ext>
             </a:extLst>
           </p:cNvPr>
@@ -3393,7 +3393,7 @@
           <p:cNvPr id="16" name="cell-0-1-180">
             <a:extLst xmlns:a="http://schemas.openxmlformats.org/drawingml/2006/main">
               <a:ext uri="{FF2B5EF4-FFF2-40B4-BE49-F238E27FC236}">
-                <a16:creationId xmlns:a16="http://schemas.microsoft.com/office/drawing/2014/main" id="{6F530435-F6B1-4817-BC7F-1F3A945DE07E}"/>
+                <a16:creationId xmlns:a16="http://schemas.microsoft.com/office/drawing/2014/main" id="{CBD0151A-8D94-4055-AAFD-1C57354C756C}"/>
               </a:ext>
             </a:extLst>
           </p:cNvPr>
@@ -3451,7 +3451,7 @@
           <p:cNvPr id="17" name="cell-bg-0-2-180">
             <a:extLst xmlns:a="http://schemas.openxmlformats.org/drawingml/2006/main">
               <a:ext uri="{FF2B5EF4-FFF2-40B4-BE49-F238E27FC236}">
-                <a16:creationId xmlns:a16="http://schemas.microsoft.com/office/drawing/2014/main" id="{1DFBBEF8-6343-4A6D-BD50-DB18DEFB4391}"/>
+                <a16:creationId xmlns:a16="http://schemas.microsoft.com/office/drawing/2014/main" id="{BA15AE83-4145-4FAC-A83C-AB31EE57C524}"/>
               </a:ext>
             </a:extLst>
           </p:cNvPr>
@@ -3484,7 +3484,7 @@
           <p:cNvPr id="18" name="cell-0-2-180">
             <a:extLst xmlns:a="http://schemas.openxmlformats.org/drawingml/2006/main">
               <a:ext uri="{FF2B5EF4-FFF2-40B4-BE49-F238E27FC236}">
-                <a16:creationId xmlns:a16="http://schemas.microsoft.com/office/drawing/2014/main" id="{3F7219B3-D5F3-4CF9-BF21-D905BFAB242B}"/>
+                <a16:creationId xmlns:a16="http://schemas.microsoft.com/office/drawing/2014/main" id="{8DC7DC6D-97A2-4D5B-8C8E-F70BAF80FAC5}"/>
               </a:ext>
             </a:extLst>
           </p:cNvPr>
@@ -3542,7 +3542,7 @@
           <p:cNvPr id="19" name="cell-bg-0-3-180">
             <a:extLst xmlns:a="http://schemas.openxmlformats.org/drawingml/2006/main">
               <a:ext uri="{FF2B5EF4-FFF2-40B4-BE49-F238E27FC236}">
-                <a16:creationId xmlns:a16="http://schemas.microsoft.com/office/drawing/2014/main" id="{6AE035BE-96E9-4738-B7A7-D016F0169280}"/>
+                <a16:creationId xmlns:a16="http://schemas.microsoft.com/office/drawing/2014/main" id="{2660ABE8-9DB9-4D7A-A4E7-1426FFC551FA}"/>
               </a:ext>
             </a:extLst>
           </p:cNvPr>
@@ -3575,7 +3575,7 @@
           <p:cNvPr id="20" name="cell-0-3-180">
             <a:extLst xmlns:a="http://schemas.openxmlformats.org/drawingml/2006/main">
               <a:ext uri="{FF2B5EF4-FFF2-40B4-BE49-F238E27FC236}">
-                <a16:creationId xmlns:a16="http://schemas.microsoft.com/office/drawing/2014/main" id="{7AF19F85-A236-4C89-8D70-E40C6E804D50}"/>
+                <a16:creationId xmlns:a16="http://schemas.microsoft.com/office/drawing/2014/main" id="{A4D2224B-3412-4ADA-95A2-B835FB3BCE2B}"/>
               </a:ext>
             </a:extLst>
           </p:cNvPr>
@@ -3633,7 +3633,7 @@
           <p:cNvPr id="21" name="cell-bg-1-0-180">
             <a:extLst xmlns:a="http://schemas.openxmlformats.org/drawingml/2006/main">
               <a:ext uri="{FF2B5EF4-FFF2-40B4-BE49-F238E27FC236}">
-                <a16:creationId xmlns:a16="http://schemas.microsoft.com/office/drawing/2014/main" id="{4B60F237-968D-454A-9217-3E8C8332848F}"/>
+                <a16:creationId xmlns:a16="http://schemas.microsoft.com/office/drawing/2014/main" id="{F108E329-7563-4F0A-A711-E52EFE31ED51}"/>
               </a:ext>
             </a:extLst>
           </p:cNvPr>
@@ -3666,7 +3666,7 @@
           <p:cNvPr id="22" name="cell-1-0-180">
             <a:extLst xmlns:a="http://schemas.openxmlformats.org/drawingml/2006/main">
               <a:ext uri="{FF2B5EF4-FFF2-40B4-BE49-F238E27FC236}">
-                <a16:creationId xmlns:a16="http://schemas.microsoft.com/office/drawing/2014/main" id="{3EF715C4-7933-4194-A4F9-466092618447}"/>
+                <a16:creationId xmlns:a16="http://schemas.microsoft.com/office/drawing/2014/main" id="{1F6C7605-8DBB-4610-A284-31DEDD32B7FD}"/>
               </a:ext>
             </a:extLst>
           </p:cNvPr>
@@ -3724,7 +3724,7 @@
           <p:cNvPr id="23" name="cell-bg-1-1-180">
             <a:extLst xmlns:a="http://schemas.openxmlformats.org/drawingml/2006/main">
               <a:ext uri="{FF2B5EF4-FFF2-40B4-BE49-F238E27FC236}">
-                <a16:creationId xmlns:a16="http://schemas.microsoft.com/office/drawing/2014/main" id="{94F0B3D9-066A-428D-813B-9886EC1E109E}"/>
+                <a16:creationId xmlns:a16="http://schemas.microsoft.com/office/drawing/2014/main" id="{85CD4A2A-4F2C-42ED-AE3E-A462991AF0EB}"/>
               </a:ext>
             </a:extLst>
           </p:cNvPr>
@@ -3757,7 +3757,7 @@
           <p:cNvPr id="24" name="cell-1-1-180">
             <a:extLst xmlns:a="http://schemas.openxmlformats.org/drawingml/2006/main">
               <a:ext uri="{FF2B5EF4-FFF2-40B4-BE49-F238E27FC236}">
-                <a16:creationId xmlns:a16="http://schemas.microsoft.com/office/drawing/2014/main" id="{B78900C9-C876-459D-9BAA-1D381C06810C}"/>
+                <a16:creationId xmlns:a16="http://schemas.microsoft.com/office/drawing/2014/main" id="{4B1A5C3D-4BEE-49B5-89B7-E567C110E0A9}"/>
               </a:ext>
             </a:extLst>
           </p:cNvPr>
@@ -3815,7 +3815,7 @@
           <p:cNvPr id="25" name="cell-bg-1-2-180">
             <a:extLst xmlns:a="http://schemas.openxmlformats.org/drawingml/2006/main">
               <a:ext uri="{FF2B5EF4-FFF2-40B4-BE49-F238E27FC236}">
-                <a16:creationId xmlns:a16="http://schemas.microsoft.com/office/drawing/2014/main" id="{CC7752D9-879C-4BAF-ABEB-3A03BBEDBFD8}"/>
+                <a16:creationId xmlns:a16="http://schemas.microsoft.com/office/drawing/2014/main" id="{D6DD2964-0DEE-4CD1-971C-D1D5317F82AF}"/>
               </a:ext>
             </a:extLst>
           </p:cNvPr>
@@ -3848,7 +3848,7 @@
           <p:cNvPr id="26" name="cell-1-2-180">
             <a:extLst xmlns:a="http://schemas.openxmlformats.org/drawingml/2006/main">
               <a:ext uri="{FF2B5EF4-FFF2-40B4-BE49-F238E27FC236}">
-                <a16:creationId xmlns:a16="http://schemas.microsoft.com/office/drawing/2014/main" id="{2C32371D-C92E-4E87-B2A7-4AB64CAD451C}"/>
+                <a16:creationId xmlns:a16="http://schemas.microsoft.com/office/drawing/2014/main" id="{5F6E685C-56D1-43FD-96B0-97755A203E5B}"/>
               </a:ext>
             </a:extLst>
           </p:cNvPr>
@@ -3906,7 +3906,7 @@
           <p:cNvPr id="27" name="cell-bg-1-3-180">
             <a:extLst xmlns:a="http://schemas.openxmlformats.org/drawingml/2006/main">
               <a:ext uri="{FF2B5EF4-FFF2-40B4-BE49-F238E27FC236}">
-                <a16:creationId xmlns:a16="http://schemas.microsoft.com/office/drawing/2014/main" id="{7B7778CD-1135-43CD-8D75-758EF4060FA7}"/>
+                <a16:creationId xmlns:a16="http://schemas.microsoft.com/office/drawing/2014/main" id="{7A3DC833-54FC-480E-A422-A870333A05A5}"/>
               </a:ext>
             </a:extLst>
           </p:cNvPr>
@@ -3939,7 +3939,7 @@
           <p:cNvPr id="28" name="cell-1-3-180">
             <a:extLst xmlns:a="http://schemas.openxmlformats.org/drawingml/2006/main">
               <a:ext uri="{FF2B5EF4-FFF2-40B4-BE49-F238E27FC236}">
-                <a16:creationId xmlns:a16="http://schemas.microsoft.com/office/drawing/2014/main" id="{CE8EB69C-743B-4050-9A02-B2B9C6529C1D}"/>
+                <a16:creationId xmlns:a16="http://schemas.microsoft.com/office/drawing/2014/main" id="{D4D43D00-4D8C-4F9B-A199-19C5A0F9AAD9}"/>
               </a:ext>
             </a:extLst>
           </p:cNvPr>
@@ -3997,7 +3997,7 @@
           <p:cNvPr id="29" name="cell-bg-2-0-180">
             <a:extLst xmlns:a="http://schemas.openxmlformats.org/drawingml/2006/main">
               <a:ext uri="{FF2B5EF4-FFF2-40B4-BE49-F238E27FC236}">
-                <a16:creationId xmlns:a16="http://schemas.microsoft.com/office/drawing/2014/main" id="{2C4BDA82-91D6-488A-94BB-5DE056E52BD9}"/>
+                <a16:creationId xmlns:a16="http://schemas.microsoft.com/office/drawing/2014/main" id="{ACB21AE4-8949-4A4F-AD4C-36C35872FB1A}"/>
               </a:ext>
             </a:extLst>
           </p:cNvPr>
@@ -4030,7 +4030,7 @@
           <p:cNvPr id="30" name="cell-2-0-180">
             <a:extLst xmlns:a="http://schemas.openxmlformats.org/drawingml/2006/main">
               <a:ext uri="{FF2B5EF4-FFF2-40B4-BE49-F238E27FC236}">
-                <a16:creationId xmlns:a16="http://schemas.microsoft.com/office/drawing/2014/main" id="{A921CBE3-58AE-411C-B0B5-4192A918EB0A}"/>
+                <a16:creationId xmlns:a16="http://schemas.microsoft.com/office/drawing/2014/main" id="{4E9E8258-943C-409D-A9FA-1A0811DA597E}"/>
               </a:ext>
             </a:extLst>
           </p:cNvPr>
@@ -4088,7 +4088,7 @@
           <p:cNvPr id="31" name="cell-bg-2-1-180">
             <a:extLst xmlns:a="http://schemas.openxmlformats.org/drawingml/2006/main">
               <a:ext uri="{FF2B5EF4-FFF2-40B4-BE49-F238E27FC236}">
-                <a16:creationId xmlns:a16="http://schemas.microsoft.com/office/drawing/2014/main" id="{D628A99D-5926-41C2-A302-9B2FEBD7DB26}"/>
+                <a16:creationId xmlns:a16="http://schemas.microsoft.com/office/drawing/2014/main" id="{D3D4E1E8-6B4F-42D8-8DE1-BC4FF3CB3941}"/>
               </a:ext>
             </a:extLst>
           </p:cNvPr>
@@ -4121,7 +4121,7 @@
           <p:cNvPr id="32" name="cell-2-1-180">
             <a:extLst xmlns:a="http://schemas.openxmlformats.org/drawingml/2006/main">
               <a:ext uri="{FF2B5EF4-FFF2-40B4-BE49-F238E27FC236}">
-                <a16:creationId xmlns:a16="http://schemas.microsoft.com/office/drawing/2014/main" id="{2E37027B-97BA-44A3-8915-E574B143E4BB}"/>
+                <a16:creationId xmlns:a16="http://schemas.microsoft.com/office/drawing/2014/main" id="{89566DC2-548B-4100-856E-4444B2A55A03}"/>
               </a:ext>
             </a:extLst>
           </p:cNvPr>
@@ -4179,7 +4179,7 @@
           <p:cNvPr id="33" name="cell-bg-2-2-180">
             <a:extLst xmlns:a="http://schemas.openxmlformats.org/drawingml/2006/main">
               <a:ext uri="{FF2B5EF4-FFF2-40B4-BE49-F238E27FC236}">
-                <a16:creationId xmlns:a16="http://schemas.microsoft.com/office/drawing/2014/main" id="{435451AF-20CC-4A10-9071-8A41CA6CCB1F}"/>
+                <a16:creationId xmlns:a16="http://schemas.microsoft.com/office/drawing/2014/main" id="{A2CBB190-B63A-40FC-B566-8938F2465472}"/>
               </a:ext>
             </a:extLst>
           </p:cNvPr>
@@ -4212,7 +4212,7 @@
           <p:cNvPr id="34" name="cell-2-2-180">
             <a:extLst xmlns:a="http://schemas.openxmlformats.org/drawingml/2006/main">
               <a:ext uri="{FF2B5EF4-FFF2-40B4-BE49-F238E27FC236}">
-                <a16:creationId xmlns:a16="http://schemas.microsoft.com/office/drawing/2014/main" id="{946F2C19-E856-4764-89DD-C9B3CF94C48D}"/>
+                <a16:creationId xmlns:a16="http://schemas.microsoft.com/office/drawing/2014/main" id="{40C72876-FCFD-4C8D-94B3-78316295F9E0}"/>
               </a:ext>
             </a:extLst>
           </p:cNvPr>
@@ -4270,7 +4270,7 @@
           <p:cNvPr id="35" name="cell-bg-2-3-180">
             <a:extLst xmlns:a="http://schemas.openxmlformats.org/drawingml/2006/main">
               <a:ext uri="{FF2B5EF4-FFF2-40B4-BE49-F238E27FC236}">
-                <a16:creationId xmlns:a16="http://schemas.microsoft.com/office/drawing/2014/main" id="{C3CEB399-ED25-44E0-A9CA-43E5BDD0D0DC}"/>
+                <a16:creationId xmlns:a16="http://schemas.microsoft.com/office/drawing/2014/main" id="{3BC5016E-434B-4095-9DF7-234DA00817DA}"/>
               </a:ext>
             </a:extLst>
           </p:cNvPr>
@@ -4303,7 +4303,7 @@
           <p:cNvPr id="36" name="cell-2-3-180">
             <a:extLst xmlns:a="http://schemas.openxmlformats.org/drawingml/2006/main">
               <a:ext uri="{FF2B5EF4-FFF2-40B4-BE49-F238E27FC236}">
-                <a16:creationId xmlns:a16="http://schemas.microsoft.com/office/drawing/2014/main" id="{AECBA353-11B0-44EA-A034-A4B8427CF3EB}"/>
+                <a16:creationId xmlns:a16="http://schemas.microsoft.com/office/drawing/2014/main" id="{46E86D42-D212-49E1-B4B4-85315CB4F0FE}"/>
               </a:ext>
             </a:extLst>
           </p:cNvPr>
@@ -4361,7 +4361,7 @@
           <p:cNvPr id="37" name="cell-bg-3-0-180">
             <a:extLst xmlns:a="http://schemas.openxmlformats.org/drawingml/2006/main">
               <a:ext uri="{FF2B5EF4-FFF2-40B4-BE49-F238E27FC236}">
-                <a16:creationId xmlns:a16="http://schemas.microsoft.com/office/drawing/2014/main" id="{14A9C59B-B1D0-4EB9-8AF9-1A02D0EAEE5C}"/>
+                <a16:creationId xmlns:a16="http://schemas.microsoft.com/office/drawing/2014/main" id="{04120642-0355-4569-BF3D-D12211A90E33}"/>
               </a:ext>
             </a:extLst>
           </p:cNvPr>
@@ -4394,7 +4394,7 @@
           <p:cNvPr id="38" name="cell-3-0-180">
             <a:extLst xmlns:a="http://schemas.openxmlformats.org/drawingml/2006/main">
               <a:ext uri="{FF2B5EF4-FFF2-40B4-BE49-F238E27FC236}">
-                <a16:creationId xmlns:a16="http://schemas.microsoft.com/office/drawing/2014/main" id="{05FCF409-6403-4F32-BB4C-5E3609AD67FA}"/>
+                <a16:creationId xmlns:a16="http://schemas.microsoft.com/office/drawing/2014/main" id="{60A0218C-7AF8-4295-B163-70DBE1B09E56}"/>
               </a:ext>
             </a:extLst>
           </p:cNvPr>
@@ -4452,7 +4452,7 @@
           <p:cNvPr id="39" name="cell-bg-3-1-180">
             <a:extLst xmlns:a="http://schemas.openxmlformats.org/drawingml/2006/main">
               <a:ext uri="{FF2B5EF4-FFF2-40B4-BE49-F238E27FC236}">
-                <a16:creationId xmlns:a16="http://schemas.microsoft.com/office/drawing/2014/main" id="{56E51F01-FBB9-4505-B93A-02A687CE3A4D}"/>
+                <a16:creationId xmlns:a16="http://schemas.microsoft.com/office/drawing/2014/main" id="{98EA456A-22B8-4BD2-809F-62210FEFE1C9}"/>
               </a:ext>
             </a:extLst>
           </p:cNvPr>
@@ -4485,7 +4485,7 @@
           <p:cNvPr id="40" name="cell-3-1-180">
             <a:extLst xmlns:a="http://schemas.openxmlformats.org/drawingml/2006/main">
               <a:ext uri="{FF2B5EF4-FFF2-40B4-BE49-F238E27FC236}">
-                <a16:creationId xmlns:a16="http://schemas.microsoft.com/office/drawing/2014/main" id="{7D26DD62-F897-4FA2-B7AD-D0882ECA95C0}"/>
+                <a16:creationId xmlns:a16="http://schemas.microsoft.com/office/drawing/2014/main" id="{3AA8830A-156C-4E57-A130-89DA47CA11E3}"/>
               </a:ext>
             </a:extLst>
           </p:cNvPr>
@@ -4543,7 +4543,7 @@
           <p:cNvPr id="41" name="cell-bg-3-2-180">
             <a:extLst xmlns:a="http://schemas.openxmlformats.org/drawingml/2006/main">
               <a:ext uri="{FF2B5EF4-FFF2-40B4-BE49-F238E27FC236}">
-                <a16:creationId xmlns:a16="http://schemas.microsoft.com/office/drawing/2014/main" id="{A2F55B8E-7BEA-4105-9A93-48A11AB1F23E}"/>
+                <a16:creationId xmlns:a16="http://schemas.microsoft.com/office/drawing/2014/main" id="{3B100D5C-AD7B-46C1-982B-7F1886B85E8C}"/>
               </a:ext>
             </a:extLst>
           </p:cNvPr>
@@ -4576,7 +4576,7 @@
           <p:cNvPr id="42" name="cell-3-2-180">
             <a:extLst xmlns:a="http://schemas.openxmlformats.org/drawingml/2006/main">
               <a:ext uri="{FF2B5EF4-FFF2-40B4-BE49-F238E27FC236}">
-                <a16:creationId xmlns:a16="http://schemas.microsoft.com/office/drawing/2014/main" id="{4108CB83-E4DD-4DF6-8E1A-914A99868E38}"/>
+                <a16:creationId xmlns:a16="http://schemas.microsoft.com/office/drawing/2014/main" id="{E008234E-3EB4-48D2-A1EF-45D014CCBB26}"/>
               </a:ext>
             </a:extLst>
           </p:cNvPr>
@@ -4634,7 +4634,7 @@
           <p:cNvPr id="43" name="cell-bg-3-3-180">
             <a:extLst xmlns:a="http://schemas.openxmlformats.org/drawingml/2006/main">
               <a:ext uri="{FF2B5EF4-FFF2-40B4-BE49-F238E27FC236}">
-                <a16:creationId xmlns:a16="http://schemas.microsoft.com/office/drawing/2014/main" id="{D9CD7657-C3A5-462F-941A-87F89A419E82}"/>
+                <a16:creationId xmlns:a16="http://schemas.microsoft.com/office/drawing/2014/main" id="{6E30C141-088B-4F51-9F04-B46B0DD3F260}"/>
               </a:ext>
             </a:extLst>
           </p:cNvPr>
@@ -4667,7 +4667,7 @@
           <p:cNvPr id="44" name="cell-3-3-180">
             <a:extLst xmlns:a="http://schemas.openxmlformats.org/drawingml/2006/main">
               <a:ext uri="{FF2B5EF4-FFF2-40B4-BE49-F238E27FC236}">
-                <a16:creationId xmlns:a16="http://schemas.microsoft.com/office/drawing/2014/main" id="{5B8598F4-3CD7-49F1-A61C-4441D0872916}"/>
+                <a16:creationId xmlns:a16="http://schemas.microsoft.com/office/drawing/2014/main" id="{823EF331-1E43-408B-AFC9-46248DE11BAC}"/>
               </a:ext>
             </a:extLst>
           </p:cNvPr>
@@ -4725,7 +4725,7 @@
           <p:cNvPr id="45" name="cell-bg-4-0-180">
             <a:extLst xmlns:a="http://schemas.openxmlformats.org/drawingml/2006/main">
               <a:ext uri="{FF2B5EF4-FFF2-40B4-BE49-F238E27FC236}">
-                <a16:creationId xmlns:a16="http://schemas.microsoft.com/office/drawing/2014/main" id="{CE43CF6E-ECE0-4A34-88B1-2B45D5A7D77B}"/>
+                <a16:creationId xmlns:a16="http://schemas.microsoft.com/office/drawing/2014/main" id="{C058A589-9B70-443A-A1FA-0F06C571D975}"/>
               </a:ext>
             </a:extLst>
           </p:cNvPr>
@@ -4758,7 +4758,7 @@
           <p:cNvPr id="46" name="cell-4-0-180">
             <a:extLst xmlns:a="http://schemas.openxmlformats.org/drawingml/2006/main">
               <a:ext uri="{FF2B5EF4-FFF2-40B4-BE49-F238E27FC236}">
-                <a16:creationId xmlns:a16="http://schemas.microsoft.com/office/drawing/2014/main" id="{A46632FE-D199-4E90-BF26-9A72348BB8BF}"/>
+                <a16:creationId xmlns:a16="http://schemas.microsoft.com/office/drawing/2014/main" id="{259842D4-CA71-4E85-A646-EA10306C98A9}"/>
               </a:ext>
             </a:extLst>
           </p:cNvPr>
@@ -4816,7 +4816,7 @@
           <p:cNvPr id="47" name="cell-bg-4-1-180">
             <a:extLst xmlns:a="http://schemas.openxmlformats.org/drawingml/2006/main">
               <a:ext uri="{FF2B5EF4-FFF2-40B4-BE49-F238E27FC236}">
-                <a16:creationId xmlns:a16="http://schemas.microsoft.com/office/drawing/2014/main" id="{C1CA7BD5-2A3B-44AB-9553-0B4BAF6497AD}"/>
+                <a16:creationId xmlns:a16="http://schemas.microsoft.com/office/drawing/2014/main" id="{A6D6ED3A-FEDD-4BF1-BDF2-9907ACF6915B}"/>
               </a:ext>
             </a:extLst>
           </p:cNvPr>
@@ -4849,7 +4849,7 @@
           <p:cNvPr id="48" name="cell-4-1-180">
             <a:extLst xmlns:a="http://schemas.openxmlformats.org/drawingml/2006/main">
               <a:ext uri="{FF2B5EF4-FFF2-40B4-BE49-F238E27FC236}">
-                <a16:creationId xmlns:a16="http://schemas.microsoft.com/office/drawing/2014/main" id="{4D0E8257-0A52-418F-97BE-DF2F0ED60039}"/>
+                <a16:creationId xmlns:a16="http://schemas.microsoft.com/office/drawing/2014/main" id="{A7852951-901D-4789-81E3-41E3A1899A40}"/>
               </a:ext>
             </a:extLst>
           </p:cNvPr>
@@ -4907,7 +4907,7 @@
           <p:cNvPr id="49" name="cell-bg-4-2-180">
             <a:extLst xmlns:a="http://schemas.openxmlformats.org/drawingml/2006/main">
               <a:ext uri="{FF2B5EF4-FFF2-40B4-BE49-F238E27FC236}">
-                <a16:creationId xmlns:a16="http://schemas.microsoft.com/office/drawing/2014/main" id="{BFFD150C-9776-46C0-BBBA-8AFA652EF4A6}"/>
+                <a16:creationId xmlns:a16="http://schemas.microsoft.com/office/drawing/2014/main" id="{A521F46D-52AD-41A4-AA3E-20F97E8582CC}"/>
               </a:ext>
             </a:extLst>
           </p:cNvPr>
@@ -4940,7 +4940,7 @@
           <p:cNvPr id="50" name="cell-4-2-180">
             <a:extLst xmlns:a="http://schemas.openxmlformats.org/drawingml/2006/main">
               <a:ext uri="{FF2B5EF4-FFF2-40B4-BE49-F238E27FC236}">
-                <a16:creationId xmlns:a16="http://schemas.microsoft.com/office/drawing/2014/main" id="{BFF519D7-F8F2-4B21-907C-1D964F788C01}"/>
+                <a16:creationId xmlns:a16="http://schemas.microsoft.com/office/drawing/2014/main" id="{BB590E62-161C-4019-B7D4-49E0B4F9DF9A}"/>
               </a:ext>
             </a:extLst>
           </p:cNvPr>
@@ -4998,7 +4998,7 @@
           <p:cNvPr id="51" name="cell-bg-4-3-180">
             <a:extLst xmlns:a="http://schemas.openxmlformats.org/drawingml/2006/main">
               <a:ext uri="{FF2B5EF4-FFF2-40B4-BE49-F238E27FC236}">
-                <a16:creationId xmlns:a16="http://schemas.microsoft.com/office/drawing/2014/main" id="{F688A6C6-0E81-4F6F-B7E4-57B9A7BCE2AB}"/>
+                <a16:creationId xmlns:a16="http://schemas.microsoft.com/office/drawing/2014/main" id="{39BF97CB-463B-42BD-A1C7-AB9256BEC805}"/>
               </a:ext>
             </a:extLst>
           </p:cNvPr>
@@ -5031,7 +5031,7 @@
           <p:cNvPr id="52" name="cell-4-3-180">
             <a:extLst xmlns:a="http://schemas.openxmlformats.org/drawingml/2006/main">
               <a:ext uri="{FF2B5EF4-FFF2-40B4-BE49-F238E27FC236}">
-                <a16:creationId xmlns:a16="http://schemas.microsoft.com/office/drawing/2014/main" id="{8031273C-1E71-42BD-A8BE-FF2C4FFEB1FB}"/>
+                <a16:creationId xmlns:a16="http://schemas.microsoft.com/office/drawing/2014/main" id="{EDB6299B-A8E9-4726-AC6E-198DBBE42B6F}"/>
               </a:ext>
             </a:extLst>
           </p:cNvPr>
@@ -5087,7 +5087,7 @@
     </p:spTree>
     <p:extLst>
       <p:ext uri="{BB962C8B-B14F-4D97-AF65-F5344CB8AC3E}">
-        <p14:creationId xmlns:p14="http://schemas.microsoft.com/office/powerpoint/2010/main" val="41418726"/>
+        <p14:creationId xmlns:p14="http://schemas.microsoft.com/office/powerpoint/2010/main" val="410197264"/>
       </p:ext>
     </p:extLst>
   </p:cSld>
@@ -5118,7 +5118,7 @@
           <p:cNvPr id="20" name="title-4">
             <a:extLst xmlns:a="http://schemas.openxmlformats.org/drawingml/2006/main">
               <a:ext uri="{FF2B5EF4-FFF2-40B4-BE49-F238E27FC236}">
-                <a16:creationId xmlns:a16="http://schemas.microsoft.com/office/drawing/2014/main" id="{7C652201-FBF9-4474-8A37-2D2DAAA2AF15}"/>
+                <a16:creationId xmlns:a16="http://schemas.microsoft.com/office/drawing/2014/main" id="{77761D7B-3CC3-4EDA-B30B-B42BB5BDADA6}"/>
               </a:ext>
             </a:extLst>
           </p:cNvPr>
@@ -5176,7 +5176,7 @@
           <p:cNvPr id="2" name="subtitle-4">
             <a:extLst xmlns:a="http://schemas.openxmlformats.org/drawingml/2006/main">
               <a:ext uri="{FF2B5EF4-FFF2-40B4-BE49-F238E27FC236}">
-                <a16:creationId xmlns:a16="http://schemas.microsoft.com/office/drawing/2014/main" id="{B01CE79C-B64C-41A6-91F1-07D2F627C7BF}"/>
+                <a16:creationId xmlns:a16="http://schemas.microsoft.com/office/drawing/2014/main" id="{F7E121EC-57AF-4BD9-89A1-2890B332D1A1}"/>
               </a:ext>
             </a:extLst>
           </p:cNvPr>
@@ -5234,7 +5234,7 @@
           <p:cNvPr id="3" name="footer-4">
             <a:extLst xmlns:a="http://schemas.openxmlformats.org/drawingml/2006/main">
               <a:ext uri="{FF2B5EF4-FFF2-40B4-BE49-F238E27FC236}">
-                <a16:creationId xmlns:a16="http://schemas.microsoft.com/office/drawing/2014/main" id="{3F58138A-5406-4FD7-92D0-2EC3A0D40FF2}"/>
+                <a16:creationId xmlns:a16="http://schemas.microsoft.com/office/drawing/2014/main" id="{D8428798-0C50-4178-90D2-C7E958D4F6EC}"/>
               </a:ext>
             </a:extLst>
           </p:cNvPr>
@@ -5282,7 +5282,7 @@
                 <a:ea typeface="PingFang SC"/>
                 <a:cs typeface="PingFang SC"/>
               </a:rPr>
-              <a:t>ShopFlow v2.6  |  shopflow-41d613d1137b</a:t>
+              <a:t>ShopFlow v2.6  |  shopflow-fcbc6c1cd435</a:t>
             </a:r>
           </a:p>
         </p:txBody>
@@ -5292,7 +5292,7 @@
           <p:cNvPr id="4" name="page-4">
             <a:extLst xmlns:a="http://schemas.openxmlformats.org/drawingml/2006/main">
               <a:ext uri="{FF2B5EF4-FFF2-40B4-BE49-F238E27FC236}">
-                <a16:creationId xmlns:a16="http://schemas.microsoft.com/office/drawing/2014/main" id="{E692ACE3-189E-4DBA-B667-EFD67CA7AB54}"/>
+                <a16:creationId xmlns:a16="http://schemas.microsoft.com/office/drawing/2014/main" id="{73C07DE8-842F-4736-BBA0-1CBE12791889}"/>
               </a:ext>
             </a:extLst>
           </p:cNvPr>
@@ -5350,7 +5350,7 @@
           <p:cNvPr id="5" name="timeline">
             <a:extLst xmlns:a="http://schemas.openxmlformats.org/drawingml/2006/main">
               <a:ext uri="{FF2B5EF4-FFF2-40B4-BE49-F238E27FC236}">
-                <a16:creationId xmlns:a16="http://schemas.microsoft.com/office/drawing/2014/main" id="{B561DB32-EB20-4505-938F-AF12843C5EF4}"/>
+                <a16:creationId xmlns:a16="http://schemas.microsoft.com/office/drawing/2014/main" id="{C364660E-242C-4298-A069-DC8CB2C616A0}"/>
               </a:ext>
             </a:extLst>
           </p:cNvPr>
@@ -5381,7 +5381,7 @@
           <p:cNvPr id="6" name="timeline-dot-0">
             <a:extLst xmlns:a="http://schemas.openxmlformats.org/drawingml/2006/main">
               <a:ext uri="{FF2B5EF4-FFF2-40B4-BE49-F238E27FC236}">
-                <a16:creationId xmlns:a16="http://schemas.microsoft.com/office/drawing/2014/main" id="{4CB46FF1-9083-41D8-94F6-C6B4A3EC3EEC}"/>
+                <a16:creationId xmlns:a16="http://schemas.microsoft.com/office/drawing/2014/main" id="{5F81DB7A-3694-44F4-944F-38D6C532B213}"/>
               </a:ext>
             </a:extLst>
           </p:cNvPr>
@@ -5412,7 +5412,7 @@
           <p:cNvPr id="7" name="timeline-time-0">
             <a:extLst xmlns:a="http://schemas.openxmlformats.org/drawingml/2006/main">
               <a:ext uri="{FF2B5EF4-FFF2-40B4-BE49-F238E27FC236}">
-                <a16:creationId xmlns:a16="http://schemas.microsoft.com/office/drawing/2014/main" id="{8F8EF6C5-1095-4829-9F23-BC7F61C0D0BA}"/>
+                <a16:creationId xmlns:a16="http://schemas.microsoft.com/office/drawing/2014/main" id="{E6ADD9BB-589A-4B56-8A70-4644CB4A52F9}"/>
               </a:ext>
             </a:extLst>
           </p:cNvPr>
@@ -5470,7 +5470,7 @@
           <p:cNvPr id="8" name="timeline-title-0">
             <a:extLst xmlns:a="http://schemas.openxmlformats.org/drawingml/2006/main">
               <a:ext uri="{FF2B5EF4-FFF2-40B4-BE49-F238E27FC236}">
-                <a16:creationId xmlns:a16="http://schemas.microsoft.com/office/drawing/2014/main" id="{4E6C95CC-3DDA-4EF8-9420-18EA04C031AB}"/>
+                <a16:creationId xmlns:a16="http://schemas.microsoft.com/office/drawing/2014/main" id="{6286DB31-974E-4C7E-A275-1378552D88E8}"/>
               </a:ext>
             </a:extLst>
           </p:cNvPr>
@@ -5528,7 +5528,7 @@
           <p:cNvPr id="9" name="timeline-owner-0">
             <a:extLst xmlns:a="http://schemas.openxmlformats.org/drawingml/2006/main">
               <a:ext uri="{FF2B5EF4-FFF2-40B4-BE49-F238E27FC236}">
-                <a16:creationId xmlns:a16="http://schemas.microsoft.com/office/drawing/2014/main" id="{5829EA5B-7270-4934-8D64-FE57BBFCEDBB}"/>
+                <a16:creationId xmlns:a16="http://schemas.microsoft.com/office/drawing/2014/main" id="{FE172FA4-1FD9-4F41-A714-2B3974A00A1B}"/>
               </a:ext>
             </a:extLst>
           </p:cNvPr>
@@ -5586,7 +5586,7 @@
           <p:cNvPr id="10" name="timeline-dot-1">
             <a:extLst xmlns:a="http://schemas.openxmlformats.org/drawingml/2006/main">
               <a:ext uri="{FF2B5EF4-FFF2-40B4-BE49-F238E27FC236}">
-                <a16:creationId xmlns:a16="http://schemas.microsoft.com/office/drawing/2014/main" id="{17B9F81C-C867-4D7E-8ACE-0E795108B151}"/>
+                <a16:creationId xmlns:a16="http://schemas.microsoft.com/office/drawing/2014/main" id="{F93200D9-47F8-44DA-8464-CE252A992680}"/>
               </a:ext>
             </a:extLst>
           </p:cNvPr>
@@ -5617,7 +5617,7 @@
           <p:cNvPr id="11" name="timeline-time-1">
             <a:extLst xmlns:a="http://schemas.openxmlformats.org/drawingml/2006/main">
               <a:ext uri="{FF2B5EF4-FFF2-40B4-BE49-F238E27FC236}">
-                <a16:creationId xmlns:a16="http://schemas.microsoft.com/office/drawing/2014/main" id="{9F9B0E18-D951-4843-B5D8-F2DDEFC131AB}"/>
+                <a16:creationId xmlns:a16="http://schemas.microsoft.com/office/drawing/2014/main" id="{AA878389-984A-49B8-812B-62CA027B09B6}"/>
               </a:ext>
             </a:extLst>
           </p:cNvPr>
@@ -5675,7 +5675,7 @@
           <p:cNvPr id="12" name="timeline-title-1">
             <a:extLst xmlns:a="http://schemas.openxmlformats.org/drawingml/2006/main">
               <a:ext uri="{FF2B5EF4-FFF2-40B4-BE49-F238E27FC236}">
-                <a16:creationId xmlns:a16="http://schemas.microsoft.com/office/drawing/2014/main" id="{2101F749-7747-413C-ABCF-EC4D105A1B42}"/>
+                <a16:creationId xmlns:a16="http://schemas.microsoft.com/office/drawing/2014/main" id="{D8A73382-BA83-422D-9954-CDF3A295BD8E}"/>
               </a:ext>
             </a:extLst>
           </p:cNvPr>
@@ -5733,7 +5733,7 @@
           <p:cNvPr id="13" name="timeline-owner-1">
             <a:extLst xmlns:a="http://schemas.openxmlformats.org/drawingml/2006/main">
               <a:ext uri="{FF2B5EF4-FFF2-40B4-BE49-F238E27FC236}">
-                <a16:creationId xmlns:a16="http://schemas.microsoft.com/office/drawing/2014/main" id="{F4053FBB-A060-428F-9744-21D55DB55E2C}"/>
+                <a16:creationId xmlns:a16="http://schemas.microsoft.com/office/drawing/2014/main" id="{9809B970-C1C5-48E0-809C-11104CD67F73}"/>
               </a:ext>
             </a:extLst>
           </p:cNvPr>
@@ -5791,7 +5791,7 @@
           <p:cNvPr id="14" name="timeline-dot-2">
             <a:extLst xmlns:a="http://schemas.openxmlformats.org/drawingml/2006/main">
               <a:ext uri="{FF2B5EF4-FFF2-40B4-BE49-F238E27FC236}">
-                <a16:creationId xmlns:a16="http://schemas.microsoft.com/office/drawing/2014/main" id="{D4A6537F-9979-4FF7-B3DB-76391AAF95F0}"/>
+                <a16:creationId xmlns:a16="http://schemas.microsoft.com/office/drawing/2014/main" id="{109C91D2-896A-456A-81D8-AC2536EB3A48}"/>
               </a:ext>
             </a:extLst>
           </p:cNvPr>
@@ -5822,7 +5822,7 @@
           <p:cNvPr id="15" name="timeline-time-2">
             <a:extLst xmlns:a="http://schemas.openxmlformats.org/drawingml/2006/main">
               <a:ext uri="{FF2B5EF4-FFF2-40B4-BE49-F238E27FC236}">
-                <a16:creationId xmlns:a16="http://schemas.microsoft.com/office/drawing/2014/main" id="{A5806579-BA9A-443A-AE15-6E8EAFE999AE}"/>
+                <a16:creationId xmlns:a16="http://schemas.microsoft.com/office/drawing/2014/main" id="{3A2A4D7D-F460-4D1F-97A0-D29637E59B0A}"/>
               </a:ext>
             </a:extLst>
           </p:cNvPr>
@@ -5880,7 +5880,7 @@
           <p:cNvPr id="16" name="timeline-title-2">
             <a:extLst xmlns:a="http://schemas.openxmlformats.org/drawingml/2006/main">
               <a:ext uri="{FF2B5EF4-FFF2-40B4-BE49-F238E27FC236}">
-                <a16:creationId xmlns:a16="http://schemas.microsoft.com/office/drawing/2014/main" id="{ABC33878-C516-4703-83C1-16B1AA429B88}"/>
+                <a16:creationId xmlns:a16="http://schemas.microsoft.com/office/drawing/2014/main" id="{5CC37E35-5021-4D1E-844B-CAAE614986EB}"/>
               </a:ext>
             </a:extLst>
           </p:cNvPr>
@@ -5938,7 +5938,7 @@
           <p:cNvPr id="17" name="timeline-owner-2">
             <a:extLst xmlns:a="http://schemas.openxmlformats.org/drawingml/2006/main">
               <a:ext uri="{FF2B5EF4-FFF2-40B4-BE49-F238E27FC236}">
-                <a16:creationId xmlns:a16="http://schemas.microsoft.com/office/drawing/2014/main" id="{833E4BED-57C0-41B1-875E-7DCB78D509B2}"/>
+                <a16:creationId xmlns:a16="http://schemas.microsoft.com/office/drawing/2014/main" id="{200483E4-BD52-4A4A-B66C-75A10C98AA3D}"/>
               </a:ext>
             </a:extLst>
           </p:cNvPr>
@@ -5996,7 +5996,7 @@
           <p:cNvPr id="18" name="decision-band">
             <a:extLst xmlns:a="http://schemas.openxmlformats.org/drawingml/2006/main">
               <a:ext uri="{FF2B5EF4-FFF2-40B4-BE49-F238E27FC236}">
-                <a16:creationId xmlns:a16="http://schemas.microsoft.com/office/drawing/2014/main" id="{E29B2DB5-9C3B-419F-92B5-E902CF651ED6}"/>
+                <a16:creationId xmlns:a16="http://schemas.microsoft.com/office/drawing/2014/main" id="{5E7C0F84-AC7C-4595-A86E-5A049287C4C7}"/>
               </a:ext>
             </a:extLst>
           </p:cNvPr>
@@ -6027,7 +6027,7 @@
           <p:cNvPr id="19" name="decision-text">
             <a:extLst xmlns:a="http://schemas.openxmlformats.org/drawingml/2006/main">
               <a:ext uri="{FF2B5EF4-FFF2-40B4-BE49-F238E27FC236}">
-                <a16:creationId xmlns:a16="http://schemas.microsoft.com/office/drawing/2014/main" id="{AE3E48BF-EAFE-48C4-BCBA-DE96AB76A969}"/>
+                <a16:creationId xmlns:a16="http://schemas.microsoft.com/office/drawing/2014/main" id="{85315101-F87E-42B3-AB8C-217C88FE9370}"/>
               </a:ext>
             </a:extLst>
           </p:cNvPr>
@@ -6083,7 +6083,7 @@
     </p:spTree>
     <p:extLst>
       <p:ext uri="{BB962C8B-B14F-4D97-AF65-F5344CB8AC3E}">
-        <p14:creationId xmlns:p14="http://schemas.microsoft.com/office/powerpoint/2010/main" val="173258424"/>
+        <p14:creationId xmlns:p14="http://schemas.microsoft.com/office/powerpoint/2010/main" val="1515752522"/>
       </p:ext>
     </p:extLst>
   </p:cSld>

</xml_diff>